<commit_message>
Add centered-layout slide to book cover template
New second slide: title/subtitle/bullets centered on the slide, with a
shrunken cover image in the bottom-left corner. Reuses slide 1's fonts,
sizes, and colors (Cambria navy title, italic muted Calibri subtitle,
Calibri charcoal bullets).

Co-Authored-By: Claude Sonnet 5 <noreply@anthropic.com>
</commit_message>
<xml_diff>
--- a/templates/book-cover-slide-template.pptx
+++ b/templates/book-cover-slide-template.pptx
@@ -6,9 +6,10 @@
   </p:sldMasterIdLst>
   <p:sldIdLst>
     <p:sldId id="256" r:id="rId2"/>
+    <p:sldId id="257" r:id="rId3"/>
   </p:sldIdLst>
   <p:notesMasterIdLst>
-    <p:notesMasterId r:id="rId3"/>
+    <p:notesMasterId r:id="rId4"/>
   </p:notesMasterIdLst>
   <p:sldSz cx="12192000" cy="6858000"/>
   <p:notesSz cx="6858000" cy="12192000"/>
@@ -526,6 +527,94 @@
             <a:fld id="{F7021451-1387-4CA6-816F-3879F97B5CBC}" type="slidenum">
               <a:rPr lang="en-US"/>
               <a:t>1</a:t>
+            </a:fld>
+            <a:endParaRPr lang="en-US"/>
+          </a:p>
+        </p:txBody>
+      </p:sp>
+    </p:spTree>
+    <p:extLst>
+      <p:ext uri="{BB962C8B-B14F-4D97-AF65-F5344CB8AC3E}">
+        <p14:creationId xmlns:p14="http://schemas.microsoft.com/office/powerpoint/2010/main" val="1024086991"/>
+      </p:ext>
+    </p:extLst>
+  </p:cSld>
+  <p:clrMapOvr>
+    <a:masterClrMapping/>
+  </p:clrMapOvr>
+</p:notes>
+</file>
+
+<file path=ppt/notesSlides/notesSlide2.xml><?xml version="1.0" encoding="utf-8"?>
+<p:notes xmlns:a="http://schemas.openxmlformats.org/drawingml/2006/main" xmlns:r="http://schemas.openxmlformats.org/officeDocument/2006/relationships" xmlns:p="http://schemas.openxmlformats.org/presentationml/2006/main">
+  <p:cSld>
+    <p:spTree>
+      <p:nvGrpSpPr>
+        <p:cNvPr id="1" name=""/>
+        <p:cNvGrpSpPr/>
+        <p:nvPr/>
+      </p:nvGrpSpPr>
+      <p:grpSpPr>
+        <a:xfrm>
+          <a:off x="0" y="0"/>
+          <a:ext cx="0" cy="0"/>
+          <a:chOff x="0" y="0"/>
+          <a:chExt cx="0" cy="0"/>
+        </a:xfrm>
+      </p:grpSpPr>
+      <p:sp>
+        <p:nvSpPr>
+          <p:cNvPr id="2" name="Slide Image Placeholder 1"/>
+          <p:cNvSpPr>
+            <a:spLocks noGrp="1" noRot="1" noChangeAspect="1"/>
+          </p:cNvSpPr>
+          <p:nvPr>
+            <p:ph type="sldImg"/>
+          </p:nvPr>
+        </p:nvSpPr>
+        <p:spPr/>
+      </p:sp>
+      <p:sp>
+        <p:nvSpPr>
+          <p:cNvPr id="3" name="Notes Placeholder 2"/>
+          <p:cNvSpPr>
+            <a:spLocks noGrp="1"/>
+          </p:cNvSpPr>
+          <p:nvPr>
+            <p:ph type="body" idx="1"/>
+          </p:nvPr>
+        </p:nvSpPr>
+        <p:spPr/>
+        <p:txBody>
+          <a:bodyPr/>
+          <a:lstStyle/>
+          <a:p>
+            <a:r>
+              <a:rPr lang="en-US" dirty="0"/>
+              <a:t/>
+            </a:r>
+            <a:endParaRPr lang="en-US" dirty="0"/>
+          </a:p>
+        </p:txBody>
+      </p:sp>
+      <p:sp>
+        <p:nvSpPr>
+          <p:cNvPr id="4" name="Slide Number Placeholder 3"/>
+          <p:cNvSpPr>
+            <a:spLocks noGrp="1"/>
+          </p:cNvSpPr>
+          <p:nvPr>
+            <p:ph type="sldNum" sz="quarter" idx="10"/>
+          </p:nvPr>
+        </p:nvSpPr>
+        <p:spPr/>
+        <p:txBody>
+          <a:bodyPr/>
+          <a:lstStyle/>
+          <a:p>
+            <a:fld id="{F7021451-1387-4CA6-816F-3879F97B5CBC}" type="slidenum">
+              <a:rPr lang="en-US"/>
+              <a:t>2</a:t>
             </a:fld>
             <a:endParaRPr lang="en-US"/>
           </a:p>
@@ -1083,6 +1172,264 @@
           <a:lstStyle/>
           <a:p>
             <a:pPr algn="l" indent="0" marL="0">
+              <a:buNone/>
+            </a:pPr>
+            <a:r>
+              <a:rPr lang="en-US" sz="1100" i="1" dirty="0">
+                <a:solidFill>
+                  <a:srgbClr val="7A7A7A"/>
+                </a:solidFill>
+                <a:latin typeface="Calibri" pitchFamily="34" charset="0"/>
+                <a:ea typeface="Calibri" pitchFamily="34" charset="-122"/>
+                <a:cs typeface="Calibri" pitchFamily="34" charset="-120"/>
+              </a:rPr>
+              <a:t>Delivering the Impossible — Mark Stringer</a:t>
+            </a:r>
+            <a:endParaRPr lang="en-US" sz="1100" dirty="0"/>
+          </a:p>
+        </p:txBody>
+      </p:sp>
+    </p:spTree>
+  </p:cSld>
+  <p:clrMapOvr>
+    <a:masterClrMapping/>
+  </p:clrMapOvr>
+</p:sld>
+</file>
+
+<file path=ppt/slides/slide2.xml><?xml version="1.0" encoding="utf-8"?>
+<p:sld xmlns:a="http://schemas.openxmlformats.org/drawingml/2006/main" xmlns:r="http://schemas.openxmlformats.org/officeDocument/2006/relationships" xmlns:p="http://schemas.openxmlformats.org/presentationml/2006/main">
+  <p:cSld name="Slide 2">
+    <p:bg>
+      <p:bgPr>
+        <a:solidFill>
+          <a:srgbClr val="FFFFFF"/>
+        </a:solidFill>
+      </p:bgPr>
+    </p:bg>
+    <p:spTree>
+      <p:nvGrpSpPr>
+        <p:cNvPr id="1" name=""/>
+        <p:cNvGrpSpPr/>
+        <p:nvPr/>
+      </p:nvGrpSpPr>
+      <p:grpSpPr>
+        <a:xfrm>
+          <a:off x="0" y="0"/>
+          <a:ext cx="0" cy="0"/>
+          <a:chOff x="0" y="0"/>
+          <a:chExt cx="0" cy="0"/>
+        </a:xfrm>
+      </p:grpSpPr>
+      <p:sp>
+        <p:nvSpPr>
+          <p:cNvPr id="2" name="Text 0"/>
+          <p:cNvSpPr txBox="1"/>
+          <p:nvPr/>
+        </p:nvSpPr>
+        <p:spPr>
+          <a:xfrm>
+            <a:off x="1371600" y="1371600"/>
+            <a:ext cx="9445752" cy="1005840"/>
+          </a:xfrm>
+          <a:prstGeom prst="rect">
+            <a:avLst/>
+          </a:prstGeom>
+          <a:noFill/>
+          <a:ln/>
+        </p:spPr>
+        <p:txBody>
+          <a:bodyPr wrap="square" lIns="0" tIns="0" rIns="0" bIns="0" rtlCol="0" anchor="t"/>
+          <a:lstStyle/>
+          <a:p>
+            <a:pPr algn="ctr" indent="0" marL="0">
+              <a:buNone/>
+            </a:pPr>
+            <a:r>
+              <a:rPr lang="en-US" sz="3600" b="1" dirty="0">
+                <a:solidFill>
+                  <a:srgbClr val="1F4E96"/>
+                </a:solidFill>
+                <a:latin typeface="Cambria" pitchFamily="34" charset="0"/>
+                <a:ea typeface="Cambria" pitchFamily="34" charset="-122"/>
+                <a:cs typeface="Cambria" pitchFamily="34" charset="-120"/>
+              </a:rPr>
+              <a:t>Click to add title</a:t>
+            </a:r>
+            <a:endParaRPr lang="en-US" sz="3600" dirty="0"/>
+          </a:p>
+        </p:txBody>
+      </p:sp>
+      <p:sp>
+        <p:nvSpPr>
+          <p:cNvPr id="3" name="Text 1"/>
+          <p:cNvSpPr txBox="1"/>
+          <p:nvPr/>
+        </p:nvSpPr>
+        <p:spPr>
+          <a:xfrm>
+            <a:off x="1371600" y="2423160"/>
+            <a:ext cx="9445752" cy="457200"/>
+          </a:xfrm>
+          <a:prstGeom prst="rect">
+            <a:avLst/>
+          </a:prstGeom>
+          <a:noFill/>
+          <a:ln/>
+        </p:spPr>
+        <p:txBody>
+          <a:bodyPr wrap="square" lIns="0" tIns="0" rIns="0" bIns="0" rtlCol="0" anchor="t"/>
+          <a:lstStyle/>
+          <a:p>
+            <a:pPr algn="ctr" indent="0" marL="0">
+              <a:buNone/>
+            </a:pPr>
+            <a:r>
+              <a:rPr lang="en-US" sz="1800" i="1" dirty="0">
+                <a:solidFill>
+                  <a:srgbClr val="7A7A7A"/>
+                </a:solidFill>
+                <a:latin typeface="Calibri" pitchFamily="34" charset="0"/>
+                <a:ea typeface="Calibri" pitchFamily="34" charset="-122"/>
+                <a:cs typeface="Calibri" pitchFamily="34" charset="-120"/>
+              </a:rPr>
+              <a:t>Click to add subtitle</a:t>
+            </a:r>
+            <a:endParaRPr lang="en-US" sz="1800" dirty="0"/>
+          </a:p>
+        </p:txBody>
+      </p:sp>
+      <p:sp>
+        <p:nvSpPr>
+          <p:cNvPr id="4" name="Text 2"/>
+          <p:cNvSpPr txBox="1"/>
+          <p:nvPr/>
+        </p:nvSpPr>
+        <p:spPr>
+          <a:xfrm>
+            <a:off x="2743200" y="3246120"/>
+            <a:ext cx="6702552" cy="2194560"/>
+          </a:xfrm>
+          <a:prstGeom prst="rect">
+            <a:avLst/>
+          </a:prstGeom>
+          <a:noFill/>
+          <a:ln/>
+        </p:spPr>
+        <p:txBody>
+          <a:bodyPr wrap="square" lIns="0" tIns="0" rIns="0" bIns="0" rtlCol="0" anchor="t"/>
+          <a:lstStyle/>
+          <a:p>
+            <a:pPr algn="l" marL="342900" indent="-342900">
+              <a:spcAft>
+                <a:spcPts val="1200"/>
+              </a:spcAft>
+              <a:buSzPct val="100000"/>
+              <a:buChar char="•"/>
+            </a:pPr>
+            <a:r>
+              <a:rPr lang="en-US" sz="1600" dirty="0">
+                <a:solidFill>
+                  <a:srgbClr val="36454F"/>
+                </a:solidFill>
+                <a:latin typeface="Calibri" pitchFamily="34" charset="0"/>
+                <a:ea typeface="Calibri" pitchFamily="34" charset="-122"/>
+                <a:cs typeface="Calibri" pitchFamily="34" charset="-120"/>
+              </a:rPr>
+              <a:t>Click to add a key point</a:t>
+            </a:r>
+            <a:endParaRPr lang="en-US" sz="1600" dirty="0"/>
+          </a:p>
+          <a:p>
+            <a:pPr algn="l" marL="342900" indent="-342900">
+              <a:spcAft>
+                <a:spcPts val="1200"/>
+              </a:spcAft>
+              <a:buSzPct val="100000"/>
+              <a:buChar char="•"/>
+            </a:pPr>
+            <a:r>
+              <a:rPr lang="en-US" sz="1600" dirty="0">
+                <a:solidFill>
+                  <a:srgbClr val="36454F"/>
+                </a:solidFill>
+                <a:latin typeface="Calibri" pitchFamily="34" charset="0"/>
+                <a:ea typeface="Calibri" pitchFamily="34" charset="-122"/>
+                <a:cs typeface="Calibri" pitchFamily="34" charset="-120"/>
+              </a:rPr>
+              <a:t>Click to add supporting detail</a:t>
+            </a:r>
+            <a:endParaRPr lang="en-US" sz="1600" dirty="0"/>
+          </a:p>
+          <a:p>
+            <a:pPr algn="l" marL="342900" indent="-342900">
+              <a:spcAft>
+                <a:spcPts val="1200"/>
+              </a:spcAft>
+              <a:buSzPct val="100000"/>
+              <a:buChar char="•"/>
+            </a:pPr>
+            <a:r>
+              <a:rPr lang="en-US" sz="1600" dirty="0">
+                <a:solidFill>
+                  <a:srgbClr val="36454F"/>
+                </a:solidFill>
+                <a:latin typeface="Calibri" pitchFamily="34" charset="0"/>
+                <a:ea typeface="Calibri" pitchFamily="34" charset="-122"/>
+                <a:cs typeface="Calibri" pitchFamily="34" charset="-120"/>
+              </a:rPr>
+              <a:t>Click to add a third point</a:t>
+            </a:r>
+            <a:endParaRPr lang="en-US" sz="1600" dirty="0"/>
+          </a:p>
+        </p:txBody>
+      </p:sp>
+      <p:pic>
+        <p:nvPicPr>
+          <p:cNvPr id="5" name="Image 0" descr="book-cover.png">    </p:cNvPr>
+          <p:cNvPicPr>
+            <a:picLocks noChangeAspect="1"/>
+          </p:cNvPicPr>
+          <p:nvPr/>
+        </p:nvPicPr>
+        <p:blipFill>
+          <a:blip r:embed="rId1"/>
+          <a:stretch>
+            <a:fillRect/>
+          </a:stretch>
+        </p:blipFill>
+        <p:spPr>
+          <a:xfrm>
+            <a:off x="457200" y="4599552"/>
+            <a:ext cx="1188720" cy="1801248"/>
+          </a:xfrm>
+          <a:prstGeom prst="rect">
+            <a:avLst/>
+          </a:prstGeom>
+        </p:spPr>
+      </p:pic>
+      <p:sp>
+        <p:nvSpPr>
+          <p:cNvPr id="6" name="Text 3"/>
+          <p:cNvSpPr txBox="1"/>
+          <p:nvPr/>
+        </p:nvSpPr>
+        <p:spPr>
+          <a:xfrm>
+            <a:off x="8076895" y="6263640"/>
+            <a:ext cx="3657600" cy="320040"/>
+          </a:xfrm>
+          <a:prstGeom prst="rect">
+            <a:avLst/>
+          </a:prstGeom>
+          <a:noFill/>
+          <a:ln/>
+        </p:spPr>
+        <p:txBody>
+          <a:bodyPr wrap="square" lIns="0" tIns="0" rIns="0" bIns="0" rtlCol="0" anchor="b"/>
+          <a:lstStyle/>
+          <a:p>
+            <a:pPr algn="r" indent="0" marL="0">
               <a:buNone/>
             </a:pPr>
             <a:r>

</xml_diff>

<commit_message>
Add section-header slide "4. project management theatre"
Third slide: single large centered title matching the deck's Cambria
navy styling, with the corner cover image and attribution caption.

Co-Authored-By: Claude Sonnet 5 <noreply@anthropic.com>
</commit_message>
<xml_diff>
--- a/templates/book-cover-slide-template.pptx
+++ b/templates/book-cover-slide-template.pptx
@@ -7,9 +7,10 @@
   <p:sldIdLst>
     <p:sldId id="256" r:id="rId2"/>
     <p:sldId id="257" r:id="rId3"/>
+    <p:sldId id="258" r:id="rId4"/>
   </p:sldIdLst>
   <p:notesMasterIdLst>
-    <p:notesMasterId r:id="rId4"/>
+    <p:notesMasterId r:id="rId5"/>
   </p:notesMasterIdLst>
   <p:sldSz cx="12192000" cy="6858000"/>
   <p:notesSz cx="6858000" cy="12192000"/>
@@ -615,6 +616,94 @@
             <a:fld id="{F7021451-1387-4CA6-816F-3879F97B5CBC}" type="slidenum">
               <a:rPr lang="en-US"/>
               <a:t>2</a:t>
+            </a:fld>
+            <a:endParaRPr lang="en-US"/>
+          </a:p>
+        </p:txBody>
+      </p:sp>
+    </p:spTree>
+    <p:extLst>
+      <p:ext uri="{BB962C8B-B14F-4D97-AF65-F5344CB8AC3E}">
+        <p14:creationId xmlns:p14="http://schemas.microsoft.com/office/powerpoint/2010/main" val="1024086991"/>
+      </p:ext>
+    </p:extLst>
+  </p:cSld>
+  <p:clrMapOvr>
+    <a:masterClrMapping/>
+  </p:clrMapOvr>
+</p:notes>
+</file>
+
+<file path=ppt/notesSlides/notesSlide3.xml><?xml version="1.0" encoding="utf-8"?>
+<p:notes xmlns:a="http://schemas.openxmlformats.org/drawingml/2006/main" xmlns:r="http://schemas.openxmlformats.org/officeDocument/2006/relationships" xmlns:p="http://schemas.openxmlformats.org/presentationml/2006/main">
+  <p:cSld>
+    <p:spTree>
+      <p:nvGrpSpPr>
+        <p:cNvPr id="1" name=""/>
+        <p:cNvGrpSpPr/>
+        <p:nvPr/>
+      </p:nvGrpSpPr>
+      <p:grpSpPr>
+        <a:xfrm>
+          <a:off x="0" y="0"/>
+          <a:ext cx="0" cy="0"/>
+          <a:chOff x="0" y="0"/>
+          <a:chExt cx="0" cy="0"/>
+        </a:xfrm>
+      </p:grpSpPr>
+      <p:sp>
+        <p:nvSpPr>
+          <p:cNvPr id="2" name="Slide Image Placeholder 1"/>
+          <p:cNvSpPr>
+            <a:spLocks noGrp="1" noRot="1" noChangeAspect="1"/>
+          </p:cNvSpPr>
+          <p:nvPr>
+            <p:ph type="sldImg"/>
+          </p:nvPr>
+        </p:nvSpPr>
+        <p:spPr/>
+      </p:sp>
+      <p:sp>
+        <p:nvSpPr>
+          <p:cNvPr id="3" name="Notes Placeholder 2"/>
+          <p:cNvSpPr>
+            <a:spLocks noGrp="1"/>
+          </p:cNvSpPr>
+          <p:nvPr>
+            <p:ph type="body" idx="1"/>
+          </p:nvPr>
+        </p:nvSpPr>
+        <p:spPr/>
+        <p:txBody>
+          <a:bodyPr/>
+          <a:lstStyle/>
+          <a:p>
+            <a:r>
+              <a:rPr lang="en-US" dirty="0"/>
+              <a:t/>
+            </a:r>
+            <a:endParaRPr lang="en-US" dirty="0"/>
+          </a:p>
+        </p:txBody>
+      </p:sp>
+      <p:sp>
+        <p:nvSpPr>
+          <p:cNvPr id="4" name="Slide Number Placeholder 3"/>
+          <p:cNvSpPr>
+            <a:spLocks noGrp="1"/>
+          </p:cNvSpPr>
+          <p:nvPr>
+            <p:ph type="sldNum" sz="quarter" idx="10"/>
+          </p:nvPr>
+        </p:nvSpPr>
+        <p:spPr/>
+        <p:txBody>
+          <a:bodyPr/>
+          <a:lstStyle/>
+          <a:p>
+            <a:fld id="{F7021451-1387-4CA6-816F-3879F97B5CBC}" type="slidenum">
+              <a:rPr lang="en-US"/>
+              <a:t>3</a:t>
             </a:fld>
             <a:endParaRPr lang="en-US"/>
           </a:p>
@@ -1411,6 +1500,140 @@
       <p:sp>
         <p:nvSpPr>
           <p:cNvPr id="6" name="Text 3"/>
+          <p:cNvSpPr txBox="1"/>
+          <p:nvPr/>
+        </p:nvSpPr>
+        <p:spPr>
+          <a:xfrm>
+            <a:off x="8076895" y="6263640"/>
+            <a:ext cx="3657600" cy="320040"/>
+          </a:xfrm>
+          <a:prstGeom prst="rect">
+            <a:avLst/>
+          </a:prstGeom>
+          <a:noFill/>
+          <a:ln/>
+        </p:spPr>
+        <p:txBody>
+          <a:bodyPr wrap="square" lIns="0" tIns="0" rIns="0" bIns="0" rtlCol="0" anchor="b"/>
+          <a:lstStyle/>
+          <a:p>
+            <a:pPr algn="r" indent="0" marL="0">
+              <a:buNone/>
+            </a:pPr>
+            <a:r>
+              <a:rPr lang="en-US" sz="1100" i="1" dirty="0">
+                <a:solidFill>
+                  <a:srgbClr val="7A7A7A"/>
+                </a:solidFill>
+                <a:latin typeface="Calibri" pitchFamily="34" charset="0"/>
+                <a:ea typeface="Calibri" pitchFamily="34" charset="-122"/>
+                <a:cs typeface="Calibri" pitchFamily="34" charset="-120"/>
+              </a:rPr>
+              <a:t>Delivering the Impossible — Mark Stringer</a:t>
+            </a:r>
+            <a:endParaRPr lang="en-US" sz="1100" dirty="0"/>
+          </a:p>
+        </p:txBody>
+      </p:sp>
+    </p:spTree>
+  </p:cSld>
+  <p:clrMapOvr>
+    <a:masterClrMapping/>
+  </p:clrMapOvr>
+</p:sld>
+</file>
+
+<file path=ppt/slides/slide3.xml><?xml version="1.0" encoding="utf-8"?>
+<p:sld xmlns:a="http://schemas.openxmlformats.org/drawingml/2006/main" xmlns:r="http://schemas.openxmlformats.org/officeDocument/2006/relationships" xmlns:p="http://schemas.openxmlformats.org/presentationml/2006/main">
+  <p:cSld name="Slide 3">
+    <p:bg>
+      <p:bgPr>
+        <a:solidFill>
+          <a:srgbClr val="FFFFFF"/>
+        </a:solidFill>
+      </p:bgPr>
+    </p:bg>
+    <p:spTree>
+      <p:nvGrpSpPr>
+        <p:cNvPr id="1" name=""/>
+        <p:cNvGrpSpPr/>
+        <p:nvPr/>
+      </p:nvGrpSpPr>
+      <p:grpSpPr>
+        <a:xfrm>
+          <a:off x="0" y="0"/>
+          <a:ext cx="0" cy="0"/>
+          <a:chOff x="0" y="0"/>
+          <a:chExt cx="0" cy="0"/>
+        </a:xfrm>
+      </p:grpSpPr>
+      <p:sp>
+        <p:nvSpPr>
+          <p:cNvPr id="2" name="Text 0"/>
+          <p:cNvSpPr txBox="1"/>
+          <p:nvPr/>
+        </p:nvSpPr>
+        <p:spPr>
+          <a:xfrm>
+            <a:off x="914400" y="0"/>
+            <a:ext cx="10360152" cy="6858000"/>
+          </a:xfrm>
+          <a:prstGeom prst="rect">
+            <a:avLst/>
+          </a:prstGeom>
+          <a:noFill/>
+          <a:ln/>
+        </p:spPr>
+        <p:txBody>
+          <a:bodyPr wrap="square" lIns="0" tIns="0" rIns="0" bIns="0" rtlCol="0" anchor="ctr"/>
+          <a:lstStyle/>
+          <a:p>
+            <a:pPr algn="ctr" indent="0" marL="0">
+              <a:buNone/>
+            </a:pPr>
+            <a:r>
+              <a:rPr lang="en-US" sz="4000" b="1" dirty="0">
+                <a:solidFill>
+                  <a:srgbClr val="1F4E96"/>
+                </a:solidFill>
+                <a:latin typeface="Cambria" pitchFamily="34" charset="0"/>
+                <a:ea typeface="Cambria" pitchFamily="34" charset="-122"/>
+                <a:cs typeface="Cambria" pitchFamily="34" charset="-120"/>
+              </a:rPr>
+              <a:t>4. project management theatre</a:t>
+            </a:r>
+            <a:endParaRPr lang="en-US" sz="4000" dirty="0"/>
+          </a:p>
+        </p:txBody>
+      </p:sp>
+      <p:pic>
+        <p:nvPicPr>
+          <p:cNvPr id="3" name="Image 0" descr="book-cover.png">    </p:cNvPr>
+          <p:cNvPicPr>
+            <a:picLocks noChangeAspect="1"/>
+          </p:cNvPicPr>
+          <p:nvPr/>
+        </p:nvPicPr>
+        <p:blipFill>
+          <a:blip r:embed="rId1"/>
+          <a:stretch>
+            <a:fillRect/>
+          </a:stretch>
+        </p:blipFill>
+        <p:spPr>
+          <a:xfrm>
+            <a:off x="457200" y="4599552"/>
+            <a:ext cx="1188720" cy="1801248"/>
+          </a:xfrm>
+          <a:prstGeom prst="rect">
+            <a:avLst/>
+          </a:prstGeom>
+        </p:spPr>
+      </p:pic>
+      <p:sp>
+        <p:nvSpPr>
+          <p:cNvPr id="4" name="Text 1"/>
           <p:cNvSpPr txBox="1"/>
           <p:nvPr/>
         </p:nvSpPr>

</xml_diff>

<commit_message>
Add section-header slides 6 and 7
"6. Shortening the odds: making smaller bets, cheating" and
"7. Upping the bet", matching the existing section-header slide style.

Co-Authored-By: Claude Sonnet 5 <noreply@anthropic.com>
</commit_message>
<xml_diff>
--- a/templates/book-cover-slide-template.pptx
+++ b/templates/book-cover-slide-template.pptx
@@ -8,9 +8,11 @@
     <p:sldId id="256" r:id="rId2"/>
     <p:sldId id="257" r:id="rId3"/>
     <p:sldId id="258" r:id="rId4"/>
+    <p:sldId id="259" r:id="rId5"/>
+    <p:sldId id="260" r:id="rId6"/>
   </p:sldIdLst>
   <p:notesMasterIdLst>
-    <p:notesMasterId r:id="rId5"/>
+    <p:notesMasterId r:id="rId7"/>
   </p:notesMasterIdLst>
   <p:sldSz cx="12192000" cy="6858000"/>
   <p:notesSz cx="6858000" cy="12192000"/>
@@ -704,6 +706,182 @@
             <a:fld id="{F7021451-1387-4CA6-816F-3879F97B5CBC}" type="slidenum">
               <a:rPr lang="en-US"/>
               <a:t>3</a:t>
+            </a:fld>
+            <a:endParaRPr lang="en-US"/>
+          </a:p>
+        </p:txBody>
+      </p:sp>
+    </p:spTree>
+    <p:extLst>
+      <p:ext uri="{BB962C8B-B14F-4D97-AF65-F5344CB8AC3E}">
+        <p14:creationId xmlns:p14="http://schemas.microsoft.com/office/powerpoint/2010/main" val="1024086991"/>
+      </p:ext>
+    </p:extLst>
+  </p:cSld>
+  <p:clrMapOvr>
+    <a:masterClrMapping/>
+  </p:clrMapOvr>
+</p:notes>
+</file>
+
+<file path=ppt/notesSlides/notesSlide4.xml><?xml version="1.0" encoding="utf-8"?>
+<p:notes xmlns:a="http://schemas.openxmlformats.org/drawingml/2006/main" xmlns:r="http://schemas.openxmlformats.org/officeDocument/2006/relationships" xmlns:p="http://schemas.openxmlformats.org/presentationml/2006/main">
+  <p:cSld>
+    <p:spTree>
+      <p:nvGrpSpPr>
+        <p:cNvPr id="1" name=""/>
+        <p:cNvGrpSpPr/>
+        <p:nvPr/>
+      </p:nvGrpSpPr>
+      <p:grpSpPr>
+        <a:xfrm>
+          <a:off x="0" y="0"/>
+          <a:ext cx="0" cy="0"/>
+          <a:chOff x="0" y="0"/>
+          <a:chExt cx="0" cy="0"/>
+        </a:xfrm>
+      </p:grpSpPr>
+      <p:sp>
+        <p:nvSpPr>
+          <p:cNvPr id="2" name="Slide Image Placeholder 1"/>
+          <p:cNvSpPr>
+            <a:spLocks noGrp="1" noRot="1" noChangeAspect="1"/>
+          </p:cNvSpPr>
+          <p:nvPr>
+            <p:ph type="sldImg"/>
+          </p:nvPr>
+        </p:nvSpPr>
+        <p:spPr/>
+      </p:sp>
+      <p:sp>
+        <p:nvSpPr>
+          <p:cNvPr id="3" name="Notes Placeholder 2"/>
+          <p:cNvSpPr>
+            <a:spLocks noGrp="1"/>
+          </p:cNvSpPr>
+          <p:nvPr>
+            <p:ph type="body" idx="1"/>
+          </p:nvPr>
+        </p:nvSpPr>
+        <p:spPr/>
+        <p:txBody>
+          <a:bodyPr/>
+          <a:lstStyle/>
+          <a:p>
+            <a:r>
+              <a:rPr lang="en-US" dirty="0"/>
+              <a:t/>
+            </a:r>
+            <a:endParaRPr lang="en-US" dirty="0"/>
+          </a:p>
+        </p:txBody>
+      </p:sp>
+      <p:sp>
+        <p:nvSpPr>
+          <p:cNvPr id="4" name="Slide Number Placeholder 3"/>
+          <p:cNvSpPr>
+            <a:spLocks noGrp="1"/>
+          </p:cNvSpPr>
+          <p:nvPr>
+            <p:ph type="sldNum" sz="quarter" idx="10"/>
+          </p:nvPr>
+        </p:nvSpPr>
+        <p:spPr/>
+        <p:txBody>
+          <a:bodyPr/>
+          <a:lstStyle/>
+          <a:p>
+            <a:fld id="{F7021451-1387-4CA6-816F-3879F97B5CBC}" type="slidenum">
+              <a:rPr lang="en-US"/>
+              <a:t>4</a:t>
+            </a:fld>
+            <a:endParaRPr lang="en-US"/>
+          </a:p>
+        </p:txBody>
+      </p:sp>
+    </p:spTree>
+    <p:extLst>
+      <p:ext uri="{BB962C8B-B14F-4D97-AF65-F5344CB8AC3E}">
+        <p14:creationId xmlns:p14="http://schemas.microsoft.com/office/powerpoint/2010/main" val="1024086991"/>
+      </p:ext>
+    </p:extLst>
+  </p:cSld>
+  <p:clrMapOvr>
+    <a:masterClrMapping/>
+  </p:clrMapOvr>
+</p:notes>
+</file>
+
+<file path=ppt/notesSlides/notesSlide5.xml><?xml version="1.0" encoding="utf-8"?>
+<p:notes xmlns:a="http://schemas.openxmlformats.org/drawingml/2006/main" xmlns:r="http://schemas.openxmlformats.org/officeDocument/2006/relationships" xmlns:p="http://schemas.openxmlformats.org/presentationml/2006/main">
+  <p:cSld>
+    <p:spTree>
+      <p:nvGrpSpPr>
+        <p:cNvPr id="1" name=""/>
+        <p:cNvGrpSpPr/>
+        <p:nvPr/>
+      </p:nvGrpSpPr>
+      <p:grpSpPr>
+        <a:xfrm>
+          <a:off x="0" y="0"/>
+          <a:ext cx="0" cy="0"/>
+          <a:chOff x="0" y="0"/>
+          <a:chExt cx="0" cy="0"/>
+        </a:xfrm>
+      </p:grpSpPr>
+      <p:sp>
+        <p:nvSpPr>
+          <p:cNvPr id="2" name="Slide Image Placeholder 1"/>
+          <p:cNvSpPr>
+            <a:spLocks noGrp="1" noRot="1" noChangeAspect="1"/>
+          </p:cNvSpPr>
+          <p:nvPr>
+            <p:ph type="sldImg"/>
+          </p:nvPr>
+        </p:nvSpPr>
+        <p:spPr/>
+      </p:sp>
+      <p:sp>
+        <p:nvSpPr>
+          <p:cNvPr id="3" name="Notes Placeholder 2"/>
+          <p:cNvSpPr>
+            <a:spLocks noGrp="1"/>
+          </p:cNvSpPr>
+          <p:nvPr>
+            <p:ph type="body" idx="1"/>
+          </p:nvPr>
+        </p:nvSpPr>
+        <p:spPr/>
+        <p:txBody>
+          <a:bodyPr/>
+          <a:lstStyle/>
+          <a:p>
+            <a:r>
+              <a:rPr lang="en-US" dirty="0"/>
+              <a:t/>
+            </a:r>
+            <a:endParaRPr lang="en-US" dirty="0"/>
+          </a:p>
+        </p:txBody>
+      </p:sp>
+      <p:sp>
+        <p:nvSpPr>
+          <p:cNvPr id="4" name="Slide Number Placeholder 3"/>
+          <p:cNvSpPr>
+            <a:spLocks noGrp="1"/>
+          </p:cNvSpPr>
+          <p:nvPr>
+            <p:ph type="sldNum" sz="quarter" idx="10"/>
+          </p:nvPr>
+        </p:nvSpPr>
+        <p:spPr/>
+        <p:txBody>
+          <a:bodyPr/>
+          <a:lstStyle/>
+          <a:p>
+            <a:fld id="{F7021451-1387-4CA6-816F-3879F97B5CBC}" type="slidenum">
+              <a:rPr lang="en-US"/>
+              <a:t>5</a:t>
             </a:fld>
             <a:endParaRPr lang="en-US"/>
           </a:p>
@@ -1678,6 +1856,274 @@
 </p:sld>
 </file>
 
+<file path=ppt/slides/slide4.xml><?xml version="1.0" encoding="utf-8"?>
+<p:sld xmlns:a="http://schemas.openxmlformats.org/drawingml/2006/main" xmlns:r="http://schemas.openxmlformats.org/officeDocument/2006/relationships" xmlns:p="http://schemas.openxmlformats.org/presentationml/2006/main">
+  <p:cSld name="Slide 4">
+    <p:bg>
+      <p:bgPr>
+        <a:solidFill>
+          <a:srgbClr val="FFFFFF"/>
+        </a:solidFill>
+      </p:bgPr>
+    </p:bg>
+    <p:spTree>
+      <p:nvGrpSpPr>
+        <p:cNvPr id="1" name=""/>
+        <p:cNvGrpSpPr/>
+        <p:nvPr/>
+      </p:nvGrpSpPr>
+      <p:grpSpPr>
+        <a:xfrm>
+          <a:off x="0" y="0"/>
+          <a:ext cx="0" cy="0"/>
+          <a:chOff x="0" y="0"/>
+          <a:chExt cx="0" cy="0"/>
+        </a:xfrm>
+      </p:grpSpPr>
+      <p:sp>
+        <p:nvSpPr>
+          <p:cNvPr id="2" name="Text 0"/>
+          <p:cNvSpPr txBox="1"/>
+          <p:nvPr/>
+        </p:nvSpPr>
+        <p:spPr>
+          <a:xfrm>
+            <a:off x="914400" y="0"/>
+            <a:ext cx="10360152" cy="6858000"/>
+          </a:xfrm>
+          <a:prstGeom prst="rect">
+            <a:avLst/>
+          </a:prstGeom>
+          <a:noFill/>
+          <a:ln/>
+        </p:spPr>
+        <p:txBody>
+          <a:bodyPr wrap="square" lIns="0" tIns="0" rIns="0" bIns="0" rtlCol="0" anchor="ctr"/>
+          <a:lstStyle/>
+          <a:p>
+            <a:pPr algn="ctr" indent="0" marL="0">
+              <a:buNone/>
+            </a:pPr>
+            <a:r>
+              <a:rPr lang="en-US" sz="4000" b="1" dirty="0">
+                <a:solidFill>
+                  <a:srgbClr val="1F4E96"/>
+                </a:solidFill>
+                <a:latin typeface="Cambria" pitchFamily="34" charset="0"/>
+                <a:ea typeface="Cambria" pitchFamily="34" charset="-122"/>
+                <a:cs typeface="Cambria" pitchFamily="34" charset="-120"/>
+              </a:rPr>
+              <a:t>6. Shortening the odds:  making smaller bets, cheating</a:t>
+            </a:r>
+            <a:endParaRPr lang="en-US" sz="4000" dirty="0"/>
+          </a:p>
+        </p:txBody>
+      </p:sp>
+      <p:pic>
+        <p:nvPicPr>
+          <p:cNvPr id="3" name="Image 0" descr="book-cover.png">    </p:cNvPr>
+          <p:cNvPicPr>
+            <a:picLocks noChangeAspect="1"/>
+          </p:cNvPicPr>
+          <p:nvPr/>
+        </p:nvPicPr>
+        <p:blipFill>
+          <a:blip r:embed="rId1"/>
+          <a:stretch>
+            <a:fillRect/>
+          </a:stretch>
+        </p:blipFill>
+        <p:spPr>
+          <a:xfrm>
+            <a:off x="457200" y="4599552"/>
+            <a:ext cx="1188720" cy="1801248"/>
+          </a:xfrm>
+          <a:prstGeom prst="rect">
+            <a:avLst/>
+          </a:prstGeom>
+        </p:spPr>
+      </p:pic>
+      <p:sp>
+        <p:nvSpPr>
+          <p:cNvPr id="4" name="Text 1"/>
+          <p:cNvSpPr txBox="1"/>
+          <p:nvPr/>
+        </p:nvSpPr>
+        <p:spPr>
+          <a:xfrm>
+            <a:off x="8076895" y="6263640"/>
+            <a:ext cx="3657600" cy="320040"/>
+          </a:xfrm>
+          <a:prstGeom prst="rect">
+            <a:avLst/>
+          </a:prstGeom>
+          <a:noFill/>
+          <a:ln/>
+        </p:spPr>
+        <p:txBody>
+          <a:bodyPr wrap="square" lIns="0" tIns="0" rIns="0" bIns="0" rtlCol="0" anchor="b"/>
+          <a:lstStyle/>
+          <a:p>
+            <a:pPr algn="r" indent="0" marL="0">
+              <a:buNone/>
+            </a:pPr>
+            <a:r>
+              <a:rPr lang="en-US" sz="1100" i="1" dirty="0">
+                <a:solidFill>
+                  <a:srgbClr val="7A7A7A"/>
+                </a:solidFill>
+                <a:latin typeface="Calibri" pitchFamily="34" charset="0"/>
+                <a:ea typeface="Calibri" pitchFamily="34" charset="-122"/>
+                <a:cs typeface="Calibri" pitchFamily="34" charset="-120"/>
+              </a:rPr>
+              <a:t>Delivering the Impossible — Mark Stringer</a:t>
+            </a:r>
+            <a:endParaRPr lang="en-US" sz="1100" dirty="0"/>
+          </a:p>
+        </p:txBody>
+      </p:sp>
+    </p:spTree>
+  </p:cSld>
+  <p:clrMapOvr>
+    <a:masterClrMapping/>
+  </p:clrMapOvr>
+</p:sld>
+</file>
+
+<file path=ppt/slides/slide5.xml><?xml version="1.0" encoding="utf-8"?>
+<p:sld xmlns:a="http://schemas.openxmlformats.org/drawingml/2006/main" xmlns:r="http://schemas.openxmlformats.org/officeDocument/2006/relationships" xmlns:p="http://schemas.openxmlformats.org/presentationml/2006/main">
+  <p:cSld name="Slide 5">
+    <p:bg>
+      <p:bgPr>
+        <a:solidFill>
+          <a:srgbClr val="FFFFFF"/>
+        </a:solidFill>
+      </p:bgPr>
+    </p:bg>
+    <p:spTree>
+      <p:nvGrpSpPr>
+        <p:cNvPr id="1" name=""/>
+        <p:cNvGrpSpPr/>
+        <p:nvPr/>
+      </p:nvGrpSpPr>
+      <p:grpSpPr>
+        <a:xfrm>
+          <a:off x="0" y="0"/>
+          <a:ext cx="0" cy="0"/>
+          <a:chOff x="0" y="0"/>
+          <a:chExt cx="0" cy="0"/>
+        </a:xfrm>
+      </p:grpSpPr>
+      <p:sp>
+        <p:nvSpPr>
+          <p:cNvPr id="2" name="Text 0"/>
+          <p:cNvSpPr txBox="1"/>
+          <p:nvPr/>
+        </p:nvSpPr>
+        <p:spPr>
+          <a:xfrm>
+            <a:off x="914400" y="0"/>
+            <a:ext cx="10360152" cy="6858000"/>
+          </a:xfrm>
+          <a:prstGeom prst="rect">
+            <a:avLst/>
+          </a:prstGeom>
+          <a:noFill/>
+          <a:ln/>
+        </p:spPr>
+        <p:txBody>
+          <a:bodyPr wrap="square" lIns="0" tIns="0" rIns="0" bIns="0" rtlCol="0" anchor="ctr"/>
+          <a:lstStyle/>
+          <a:p>
+            <a:pPr algn="ctr" indent="0" marL="0">
+              <a:buNone/>
+            </a:pPr>
+            <a:r>
+              <a:rPr lang="en-US" sz="4000" b="1" dirty="0">
+                <a:solidFill>
+                  <a:srgbClr val="1F4E96"/>
+                </a:solidFill>
+                <a:latin typeface="Cambria" pitchFamily="34" charset="0"/>
+                <a:ea typeface="Cambria" pitchFamily="34" charset="-122"/>
+                <a:cs typeface="Cambria" pitchFamily="34" charset="-120"/>
+              </a:rPr>
+              <a:t>7. Upping the bet</a:t>
+            </a:r>
+            <a:endParaRPr lang="en-US" sz="4000" dirty="0"/>
+          </a:p>
+        </p:txBody>
+      </p:sp>
+      <p:pic>
+        <p:nvPicPr>
+          <p:cNvPr id="3" name="Image 0" descr="book-cover.png">    </p:cNvPr>
+          <p:cNvPicPr>
+            <a:picLocks noChangeAspect="1"/>
+          </p:cNvPicPr>
+          <p:nvPr/>
+        </p:nvPicPr>
+        <p:blipFill>
+          <a:blip r:embed="rId1"/>
+          <a:stretch>
+            <a:fillRect/>
+          </a:stretch>
+        </p:blipFill>
+        <p:spPr>
+          <a:xfrm>
+            <a:off x="457200" y="4599552"/>
+            <a:ext cx="1188720" cy="1801248"/>
+          </a:xfrm>
+          <a:prstGeom prst="rect">
+            <a:avLst/>
+          </a:prstGeom>
+        </p:spPr>
+      </p:pic>
+      <p:sp>
+        <p:nvSpPr>
+          <p:cNvPr id="4" name="Text 1"/>
+          <p:cNvSpPr txBox="1"/>
+          <p:nvPr/>
+        </p:nvSpPr>
+        <p:spPr>
+          <a:xfrm>
+            <a:off x="8076895" y="6263640"/>
+            <a:ext cx="3657600" cy="320040"/>
+          </a:xfrm>
+          <a:prstGeom prst="rect">
+            <a:avLst/>
+          </a:prstGeom>
+          <a:noFill/>
+          <a:ln/>
+        </p:spPr>
+        <p:txBody>
+          <a:bodyPr wrap="square" lIns="0" tIns="0" rIns="0" bIns="0" rtlCol="0" anchor="b"/>
+          <a:lstStyle/>
+          <a:p>
+            <a:pPr algn="r" indent="0" marL="0">
+              <a:buNone/>
+            </a:pPr>
+            <a:r>
+              <a:rPr lang="en-US" sz="1100" i="1" dirty="0">
+                <a:solidFill>
+                  <a:srgbClr val="7A7A7A"/>
+                </a:solidFill>
+                <a:latin typeface="Calibri" pitchFamily="34" charset="0"/>
+                <a:ea typeface="Calibri" pitchFamily="34" charset="-122"/>
+                <a:cs typeface="Calibri" pitchFamily="34" charset="-120"/>
+              </a:rPr>
+              <a:t>Delivering the Impossible — Mark Stringer</a:t>
+            </a:r>
+            <a:endParaRPr lang="en-US" sz="1100" dirty="0"/>
+          </a:p>
+        </p:txBody>
+      </p:sp>
+    </p:spTree>
+  </p:cSld>
+  <p:clrMapOvr>
+    <a:masterClrMapping/>
+  </p:clrMapOvr>
+</p:sld>
+</file>
+
 <file path=ppt/theme/theme1.xml><?xml version="1.0" encoding="utf-8"?>
 <a:theme xmlns:a="http://schemas.openxmlformats.org/drawingml/2006/main" name="Office Theme">
   <a:themeElements>

</xml_diff>

<commit_message>
Add section-header slide 8
"8. Some things aren't bets", matching the existing section-header slide style.

Co-Authored-By: Claude Sonnet 5 <noreply@anthropic.com>
</commit_message>
<xml_diff>
--- a/templates/book-cover-slide-template.pptx
+++ b/templates/book-cover-slide-template.pptx
@@ -10,9 +10,10 @@
     <p:sldId id="258" r:id="rId4"/>
     <p:sldId id="259" r:id="rId5"/>
     <p:sldId id="260" r:id="rId6"/>
+    <p:sldId id="261" r:id="rId7"/>
   </p:sldIdLst>
   <p:notesMasterIdLst>
-    <p:notesMasterId r:id="rId7"/>
+    <p:notesMasterId r:id="rId8"/>
   </p:notesMasterIdLst>
   <p:sldSz cx="12192000" cy="6858000"/>
   <p:notesSz cx="6858000" cy="12192000"/>
@@ -882,6 +883,94 @@
             <a:fld id="{F7021451-1387-4CA6-816F-3879F97B5CBC}" type="slidenum">
               <a:rPr lang="en-US"/>
               <a:t>5</a:t>
+            </a:fld>
+            <a:endParaRPr lang="en-US"/>
+          </a:p>
+        </p:txBody>
+      </p:sp>
+    </p:spTree>
+    <p:extLst>
+      <p:ext uri="{BB962C8B-B14F-4D97-AF65-F5344CB8AC3E}">
+        <p14:creationId xmlns:p14="http://schemas.microsoft.com/office/powerpoint/2010/main" val="1024086991"/>
+      </p:ext>
+    </p:extLst>
+  </p:cSld>
+  <p:clrMapOvr>
+    <a:masterClrMapping/>
+  </p:clrMapOvr>
+</p:notes>
+</file>
+
+<file path=ppt/notesSlides/notesSlide6.xml><?xml version="1.0" encoding="utf-8"?>
+<p:notes xmlns:a="http://schemas.openxmlformats.org/drawingml/2006/main" xmlns:r="http://schemas.openxmlformats.org/officeDocument/2006/relationships" xmlns:p="http://schemas.openxmlformats.org/presentationml/2006/main">
+  <p:cSld>
+    <p:spTree>
+      <p:nvGrpSpPr>
+        <p:cNvPr id="1" name=""/>
+        <p:cNvGrpSpPr/>
+        <p:nvPr/>
+      </p:nvGrpSpPr>
+      <p:grpSpPr>
+        <a:xfrm>
+          <a:off x="0" y="0"/>
+          <a:ext cx="0" cy="0"/>
+          <a:chOff x="0" y="0"/>
+          <a:chExt cx="0" cy="0"/>
+        </a:xfrm>
+      </p:grpSpPr>
+      <p:sp>
+        <p:nvSpPr>
+          <p:cNvPr id="2" name="Slide Image Placeholder 1"/>
+          <p:cNvSpPr>
+            <a:spLocks noGrp="1" noRot="1" noChangeAspect="1"/>
+          </p:cNvSpPr>
+          <p:nvPr>
+            <p:ph type="sldImg"/>
+          </p:nvPr>
+        </p:nvSpPr>
+        <p:spPr/>
+      </p:sp>
+      <p:sp>
+        <p:nvSpPr>
+          <p:cNvPr id="3" name="Notes Placeholder 2"/>
+          <p:cNvSpPr>
+            <a:spLocks noGrp="1"/>
+          </p:cNvSpPr>
+          <p:nvPr>
+            <p:ph type="body" idx="1"/>
+          </p:nvPr>
+        </p:nvSpPr>
+        <p:spPr/>
+        <p:txBody>
+          <a:bodyPr/>
+          <a:lstStyle/>
+          <a:p>
+            <a:r>
+              <a:rPr lang="en-US" dirty="0"/>
+              <a:t/>
+            </a:r>
+            <a:endParaRPr lang="en-US" dirty="0"/>
+          </a:p>
+        </p:txBody>
+      </p:sp>
+      <p:sp>
+        <p:nvSpPr>
+          <p:cNvPr id="4" name="Slide Number Placeholder 3"/>
+          <p:cNvSpPr>
+            <a:spLocks noGrp="1"/>
+          </p:cNvSpPr>
+          <p:nvPr>
+            <p:ph type="sldNum" sz="quarter" idx="10"/>
+          </p:nvPr>
+        </p:nvSpPr>
+        <p:spPr/>
+        <p:txBody>
+          <a:bodyPr/>
+          <a:lstStyle/>
+          <a:p>
+            <a:fld id="{F7021451-1387-4CA6-816F-3879F97B5CBC}" type="slidenum">
+              <a:rPr lang="en-US"/>
+              <a:t>6</a:t>
             </a:fld>
             <a:endParaRPr lang="en-US"/>
           </a:p>
@@ -2124,6 +2213,140 @@
 </p:sld>
 </file>
 
+<file path=ppt/slides/slide6.xml><?xml version="1.0" encoding="utf-8"?>
+<p:sld xmlns:a="http://schemas.openxmlformats.org/drawingml/2006/main" xmlns:r="http://schemas.openxmlformats.org/officeDocument/2006/relationships" xmlns:p="http://schemas.openxmlformats.org/presentationml/2006/main">
+  <p:cSld name="Slide 6">
+    <p:bg>
+      <p:bgPr>
+        <a:solidFill>
+          <a:srgbClr val="FFFFFF"/>
+        </a:solidFill>
+      </p:bgPr>
+    </p:bg>
+    <p:spTree>
+      <p:nvGrpSpPr>
+        <p:cNvPr id="1" name=""/>
+        <p:cNvGrpSpPr/>
+        <p:nvPr/>
+      </p:nvGrpSpPr>
+      <p:grpSpPr>
+        <a:xfrm>
+          <a:off x="0" y="0"/>
+          <a:ext cx="0" cy="0"/>
+          <a:chOff x="0" y="0"/>
+          <a:chExt cx="0" cy="0"/>
+        </a:xfrm>
+      </p:grpSpPr>
+      <p:sp>
+        <p:nvSpPr>
+          <p:cNvPr id="2" name="Text 0"/>
+          <p:cNvSpPr txBox="1"/>
+          <p:nvPr/>
+        </p:nvSpPr>
+        <p:spPr>
+          <a:xfrm>
+            <a:off x="914400" y="0"/>
+            <a:ext cx="10360152" cy="6858000"/>
+          </a:xfrm>
+          <a:prstGeom prst="rect">
+            <a:avLst/>
+          </a:prstGeom>
+          <a:noFill/>
+          <a:ln/>
+        </p:spPr>
+        <p:txBody>
+          <a:bodyPr wrap="square" lIns="0" tIns="0" rIns="0" bIns="0" rtlCol="0" anchor="ctr"/>
+          <a:lstStyle/>
+          <a:p>
+            <a:pPr algn="ctr" indent="0" marL="0">
+              <a:buNone/>
+            </a:pPr>
+            <a:r>
+              <a:rPr lang="en-US" sz="4000" b="1" dirty="0">
+                <a:solidFill>
+                  <a:srgbClr val="1F4E96"/>
+                </a:solidFill>
+                <a:latin typeface="Cambria" pitchFamily="34" charset="0"/>
+                <a:ea typeface="Cambria" pitchFamily="34" charset="-122"/>
+                <a:cs typeface="Cambria" pitchFamily="34" charset="-120"/>
+              </a:rPr>
+              <a:t>8. Some things aren't bets</a:t>
+            </a:r>
+            <a:endParaRPr lang="en-US" sz="4000" dirty="0"/>
+          </a:p>
+        </p:txBody>
+      </p:sp>
+      <p:pic>
+        <p:nvPicPr>
+          <p:cNvPr id="3" name="Image 0" descr="book-cover.png">    </p:cNvPr>
+          <p:cNvPicPr>
+            <a:picLocks noChangeAspect="1"/>
+          </p:cNvPicPr>
+          <p:nvPr/>
+        </p:nvPicPr>
+        <p:blipFill>
+          <a:blip r:embed="rId1"/>
+          <a:stretch>
+            <a:fillRect/>
+          </a:stretch>
+        </p:blipFill>
+        <p:spPr>
+          <a:xfrm>
+            <a:off x="457200" y="4599552"/>
+            <a:ext cx="1188720" cy="1801248"/>
+          </a:xfrm>
+          <a:prstGeom prst="rect">
+            <a:avLst/>
+          </a:prstGeom>
+        </p:spPr>
+      </p:pic>
+      <p:sp>
+        <p:nvSpPr>
+          <p:cNvPr id="4" name="Text 1"/>
+          <p:cNvSpPr txBox="1"/>
+          <p:nvPr/>
+        </p:nvSpPr>
+        <p:spPr>
+          <a:xfrm>
+            <a:off x="8076895" y="6263640"/>
+            <a:ext cx="3657600" cy="320040"/>
+          </a:xfrm>
+          <a:prstGeom prst="rect">
+            <a:avLst/>
+          </a:prstGeom>
+          <a:noFill/>
+          <a:ln/>
+        </p:spPr>
+        <p:txBody>
+          <a:bodyPr wrap="square" lIns="0" tIns="0" rIns="0" bIns="0" rtlCol="0" anchor="b"/>
+          <a:lstStyle/>
+          <a:p>
+            <a:pPr algn="r" indent="0" marL="0">
+              <a:buNone/>
+            </a:pPr>
+            <a:r>
+              <a:rPr lang="en-US" sz="1100" i="1" dirty="0">
+                <a:solidFill>
+                  <a:srgbClr val="7A7A7A"/>
+                </a:solidFill>
+                <a:latin typeface="Calibri" pitchFamily="34" charset="0"/>
+                <a:ea typeface="Calibri" pitchFamily="34" charset="-122"/>
+                <a:cs typeface="Calibri" pitchFamily="34" charset="-120"/>
+              </a:rPr>
+              <a:t>Delivering the Impossible — Mark Stringer</a:t>
+            </a:r>
+            <a:endParaRPr lang="en-US" sz="1100" dirty="0"/>
+          </a:p>
+        </p:txBody>
+      </p:sp>
+    </p:spTree>
+  </p:cSld>
+  <p:clrMapOvr>
+    <a:masterClrMapping/>
+  </p:clrMapOvr>
+</p:sld>
+</file>
+
 <file path=ppt/theme/theme1.xml><?xml version="1.0" encoding="utf-8"?>
 <a:theme xmlns:a="http://schemas.openxmlformats.org/drawingml/2006/main" name="Office Theme">
   <a:themeElements>

</xml_diff>

<commit_message>
Add section-header slide 9
"9. The Archbishop of Canterbury and nonsense accumulators", matching
the existing section-header slide style.

Co-Authored-By: Claude Sonnet 5 <noreply@anthropic.com>
</commit_message>
<xml_diff>
--- a/templates/book-cover-slide-template.pptx
+++ b/templates/book-cover-slide-template.pptx
@@ -11,9 +11,10 @@
     <p:sldId id="259" r:id="rId5"/>
     <p:sldId id="260" r:id="rId6"/>
     <p:sldId id="261" r:id="rId7"/>
+    <p:sldId id="262" r:id="rId8"/>
   </p:sldIdLst>
   <p:notesMasterIdLst>
-    <p:notesMasterId r:id="rId8"/>
+    <p:notesMasterId r:id="rId9"/>
   </p:notesMasterIdLst>
   <p:sldSz cx="12192000" cy="6858000"/>
   <p:notesSz cx="6858000" cy="12192000"/>
@@ -971,6 +972,94 @@
             <a:fld id="{F7021451-1387-4CA6-816F-3879F97B5CBC}" type="slidenum">
               <a:rPr lang="en-US"/>
               <a:t>6</a:t>
+            </a:fld>
+            <a:endParaRPr lang="en-US"/>
+          </a:p>
+        </p:txBody>
+      </p:sp>
+    </p:spTree>
+    <p:extLst>
+      <p:ext uri="{BB962C8B-B14F-4D97-AF65-F5344CB8AC3E}">
+        <p14:creationId xmlns:p14="http://schemas.microsoft.com/office/powerpoint/2010/main" val="1024086991"/>
+      </p:ext>
+    </p:extLst>
+  </p:cSld>
+  <p:clrMapOvr>
+    <a:masterClrMapping/>
+  </p:clrMapOvr>
+</p:notes>
+</file>
+
+<file path=ppt/notesSlides/notesSlide7.xml><?xml version="1.0" encoding="utf-8"?>
+<p:notes xmlns:a="http://schemas.openxmlformats.org/drawingml/2006/main" xmlns:r="http://schemas.openxmlformats.org/officeDocument/2006/relationships" xmlns:p="http://schemas.openxmlformats.org/presentationml/2006/main">
+  <p:cSld>
+    <p:spTree>
+      <p:nvGrpSpPr>
+        <p:cNvPr id="1" name=""/>
+        <p:cNvGrpSpPr/>
+        <p:nvPr/>
+      </p:nvGrpSpPr>
+      <p:grpSpPr>
+        <a:xfrm>
+          <a:off x="0" y="0"/>
+          <a:ext cx="0" cy="0"/>
+          <a:chOff x="0" y="0"/>
+          <a:chExt cx="0" cy="0"/>
+        </a:xfrm>
+      </p:grpSpPr>
+      <p:sp>
+        <p:nvSpPr>
+          <p:cNvPr id="2" name="Slide Image Placeholder 1"/>
+          <p:cNvSpPr>
+            <a:spLocks noGrp="1" noRot="1" noChangeAspect="1"/>
+          </p:cNvSpPr>
+          <p:nvPr>
+            <p:ph type="sldImg"/>
+          </p:nvPr>
+        </p:nvSpPr>
+        <p:spPr/>
+      </p:sp>
+      <p:sp>
+        <p:nvSpPr>
+          <p:cNvPr id="3" name="Notes Placeholder 2"/>
+          <p:cNvSpPr>
+            <a:spLocks noGrp="1"/>
+          </p:cNvSpPr>
+          <p:nvPr>
+            <p:ph type="body" idx="1"/>
+          </p:nvPr>
+        </p:nvSpPr>
+        <p:spPr/>
+        <p:txBody>
+          <a:bodyPr/>
+          <a:lstStyle/>
+          <a:p>
+            <a:r>
+              <a:rPr lang="en-US" dirty="0"/>
+              <a:t/>
+            </a:r>
+            <a:endParaRPr lang="en-US" dirty="0"/>
+          </a:p>
+        </p:txBody>
+      </p:sp>
+      <p:sp>
+        <p:nvSpPr>
+          <p:cNvPr id="4" name="Slide Number Placeholder 3"/>
+          <p:cNvSpPr>
+            <a:spLocks noGrp="1"/>
+          </p:cNvSpPr>
+          <p:nvPr>
+            <p:ph type="sldNum" sz="quarter" idx="10"/>
+          </p:nvPr>
+        </p:nvSpPr>
+        <p:spPr/>
+        <p:txBody>
+          <a:bodyPr/>
+          <a:lstStyle/>
+          <a:p>
+            <a:fld id="{F7021451-1387-4CA6-816F-3879F97B5CBC}" type="slidenum">
+              <a:rPr lang="en-US"/>
+              <a:t>7</a:t>
             </a:fld>
             <a:endParaRPr lang="en-US"/>
           </a:p>
@@ -2347,6 +2436,140 @@
 </p:sld>
 </file>
 
+<file path=ppt/slides/slide7.xml><?xml version="1.0" encoding="utf-8"?>
+<p:sld xmlns:a="http://schemas.openxmlformats.org/drawingml/2006/main" xmlns:r="http://schemas.openxmlformats.org/officeDocument/2006/relationships" xmlns:p="http://schemas.openxmlformats.org/presentationml/2006/main">
+  <p:cSld name="Slide 7">
+    <p:bg>
+      <p:bgPr>
+        <a:solidFill>
+          <a:srgbClr val="FFFFFF"/>
+        </a:solidFill>
+      </p:bgPr>
+    </p:bg>
+    <p:spTree>
+      <p:nvGrpSpPr>
+        <p:cNvPr id="1" name=""/>
+        <p:cNvGrpSpPr/>
+        <p:nvPr/>
+      </p:nvGrpSpPr>
+      <p:grpSpPr>
+        <a:xfrm>
+          <a:off x="0" y="0"/>
+          <a:ext cx="0" cy="0"/>
+          <a:chOff x="0" y="0"/>
+          <a:chExt cx="0" cy="0"/>
+        </a:xfrm>
+      </p:grpSpPr>
+      <p:sp>
+        <p:nvSpPr>
+          <p:cNvPr id="2" name="Text 0"/>
+          <p:cNvSpPr txBox="1"/>
+          <p:nvPr/>
+        </p:nvSpPr>
+        <p:spPr>
+          <a:xfrm>
+            <a:off x="914400" y="0"/>
+            <a:ext cx="10360152" cy="6858000"/>
+          </a:xfrm>
+          <a:prstGeom prst="rect">
+            <a:avLst/>
+          </a:prstGeom>
+          <a:noFill/>
+          <a:ln/>
+        </p:spPr>
+        <p:txBody>
+          <a:bodyPr wrap="square" lIns="0" tIns="0" rIns="0" bIns="0" rtlCol="0" anchor="ctr"/>
+          <a:lstStyle/>
+          <a:p>
+            <a:pPr algn="ctr" indent="0" marL="0">
+              <a:buNone/>
+            </a:pPr>
+            <a:r>
+              <a:rPr lang="en-US" sz="4000" b="1" dirty="0">
+                <a:solidFill>
+                  <a:srgbClr val="1F4E96"/>
+                </a:solidFill>
+                <a:latin typeface="Cambria" pitchFamily="34" charset="0"/>
+                <a:ea typeface="Cambria" pitchFamily="34" charset="-122"/>
+                <a:cs typeface="Cambria" pitchFamily="34" charset="-120"/>
+              </a:rPr>
+              <a:t>9. The Archbishop of Canterbury and nonsense accumulators</a:t>
+            </a:r>
+            <a:endParaRPr lang="en-US" sz="4000" dirty="0"/>
+          </a:p>
+        </p:txBody>
+      </p:sp>
+      <p:pic>
+        <p:nvPicPr>
+          <p:cNvPr id="3" name="Image 0" descr="book-cover.png">    </p:cNvPr>
+          <p:cNvPicPr>
+            <a:picLocks noChangeAspect="1"/>
+          </p:cNvPicPr>
+          <p:nvPr/>
+        </p:nvPicPr>
+        <p:blipFill>
+          <a:blip r:embed="rId1"/>
+          <a:stretch>
+            <a:fillRect/>
+          </a:stretch>
+        </p:blipFill>
+        <p:spPr>
+          <a:xfrm>
+            <a:off x="457200" y="4599552"/>
+            <a:ext cx="1188720" cy="1801248"/>
+          </a:xfrm>
+          <a:prstGeom prst="rect">
+            <a:avLst/>
+          </a:prstGeom>
+        </p:spPr>
+      </p:pic>
+      <p:sp>
+        <p:nvSpPr>
+          <p:cNvPr id="4" name="Text 1"/>
+          <p:cNvSpPr txBox="1"/>
+          <p:nvPr/>
+        </p:nvSpPr>
+        <p:spPr>
+          <a:xfrm>
+            <a:off x="8076895" y="6263640"/>
+            <a:ext cx="3657600" cy="320040"/>
+          </a:xfrm>
+          <a:prstGeom prst="rect">
+            <a:avLst/>
+          </a:prstGeom>
+          <a:noFill/>
+          <a:ln/>
+        </p:spPr>
+        <p:txBody>
+          <a:bodyPr wrap="square" lIns="0" tIns="0" rIns="0" bIns="0" rtlCol="0" anchor="b"/>
+          <a:lstStyle/>
+          <a:p>
+            <a:pPr algn="r" indent="0" marL="0">
+              <a:buNone/>
+            </a:pPr>
+            <a:r>
+              <a:rPr lang="en-US" sz="1100" i="1" dirty="0">
+                <a:solidFill>
+                  <a:srgbClr val="7A7A7A"/>
+                </a:solidFill>
+                <a:latin typeface="Calibri" pitchFamily="34" charset="0"/>
+                <a:ea typeface="Calibri" pitchFamily="34" charset="-122"/>
+                <a:cs typeface="Calibri" pitchFamily="34" charset="-120"/>
+              </a:rPr>
+              <a:t>Delivering the Impossible — Mark Stringer</a:t>
+            </a:r>
+            <a:endParaRPr lang="en-US" sz="1100" dirty="0"/>
+          </a:p>
+        </p:txBody>
+      </p:sp>
+    </p:spTree>
+  </p:cSld>
+  <p:clrMapOvr>
+    <a:masterClrMapping/>
+  </p:clrMapOvr>
+</p:sld>
+</file>
+
 <file path=ppt/theme/theme1.xml><?xml version="1.0" encoding="utf-8"?>
 <a:theme xmlns:a="http://schemas.openxmlformats.org/drawingml/2006/main" name="Office Theme">
   <a:themeElements>

</xml_diff>

<commit_message>
Add section-header slides 10-13
"10. Bricks without straw", "11. The baby seal and the big bad dog",
"12. Should you stay or should you go?", "13. Looking glass poker" —
matching the existing section-header slide style.

Co-Authored-By: Claude Sonnet 5 <noreply@anthropic.com>
</commit_message>
<xml_diff>
--- a/templates/book-cover-slide-template.pptx
+++ b/templates/book-cover-slide-template.pptx
@@ -12,9 +12,13 @@
     <p:sldId id="260" r:id="rId6"/>
     <p:sldId id="261" r:id="rId7"/>
     <p:sldId id="262" r:id="rId8"/>
+    <p:sldId id="263" r:id="rId9"/>
+    <p:sldId id="264" r:id="rId10"/>
+    <p:sldId id="265" r:id="rId11"/>
+    <p:sldId id="266" r:id="rId12"/>
   </p:sldIdLst>
   <p:notesMasterIdLst>
-    <p:notesMasterId r:id="rId9"/>
+    <p:notesMasterId r:id="rId13"/>
   </p:notesMasterIdLst>
   <p:sldSz cx="12192000" cy="6858000"/>
   <p:notesSz cx="6858000" cy="12192000"/>
@@ -550,6 +554,182 @@
 </p:notes>
 </file>
 
+<file path=ppt/notesSlides/notesSlide10.xml><?xml version="1.0" encoding="utf-8"?>
+<p:notes xmlns:a="http://schemas.openxmlformats.org/drawingml/2006/main" xmlns:r="http://schemas.openxmlformats.org/officeDocument/2006/relationships" xmlns:p="http://schemas.openxmlformats.org/presentationml/2006/main">
+  <p:cSld>
+    <p:spTree>
+      <p:nvGrpSpPr>
+        <p:cNvPr id="1" name=""/>
+        <p:cNvGrpSpPr/>
+        <p:nvPr/>
+      </p:nvGrpSpPr>
+      <p:grpSpPr>
+        <a:xfrm>
+          <a:off x="0" y="0"/>
+          <a:ext cx="0" cy="0"/>
+          <a:chOff x="0" y="0"/>
+          <a:chExt cx="0" cy="0"/>
+        </a:xfrm>
+      </p:grpSpPr>
+      <p:sp>
+        <p:nvSpPr>
+          <p:cNvPr id="2" name="Slide Image Placeholder 1"/>
+          <p:cNvSpPr>
+            <a:spLocks noGrp="1" noRot="1" noChangeAspect="1"/>
+          </p:cNvSpPr>
+          <p:nvPr>
+            <p:ph type="sldImg"/>
+          </p:nvPr>
+        </p:nvSpPr>
+        <p:spPr/>
+      </p:sp>
+      <p:sp>
+        <p:nvSpPr>
+          <p:cNvPr id="3" name="Notes Placeholder 2"/>
+          <p:cNvSpPr>
+            <a:spLocks noGrp="1"/>
+          </p:cNvSpPr>
+          <p:nvPr>
+            <p:ph type="body" idx="1"/>
+          </p:nvPr>
+        </p:nvSpPr>
+        <p:spPr/>
+        <p:txBody>
+          <a:bodyPr/>
+          <a:lstStyle/>
+          <a:p>
+            <a:r>
+              <a:rPr lang="en-US" dirty="0"/>
+              <a:t/>
+            </a:r>
+            <a:endParaRPr lang="en-US" dirty="0"/>
+          </a:p>
+        </p:txBody>
+      </p:sp>
+      <p:sp>
+        <p:nvSpPr>
+          <p:cNvPr id="4" name="Slide Number Placeholder 3"/>
+          <p:cNvSpPr>
+            <a:spLocks noGrp="1"/>
+          </p:cNvSpPr>
+          <p:nvPr>
+            <p:ph type="sldNum" sz="quarter" idx="10"/>
+          </p:nvPr>
+        </p:nvSpPr>
+        <p:spPr/>
+        <p:txBody>
+          <a:bodyPr/>
+          <a:lstStyle/>
+          <a:p>
+            <a:fld id="{F7021451-1387-4CA6-816F-3879F97B5CBC}" type="slidenum">
+              <a:rPr lang="en-US"/>
+              <a:t>10</a:t>
+            </a:fld>
+            <a:endParaRPr lang="en-US"/>
+          </a:p>
+        </p:txBody>
+      </p:sp>
+    </p:spTree>
+    <p:extLst>
+      <p:ext uri="{BB962C8B-B14F-4D97-AF65-F5344CB8AC3E}">
+        <p14:creationId xmlns:p14="http://schemas.microsoft.com/office/powerpoint/2010/main" val="1024086991"/>
+      </p:ext>
+    </p:extLst>
+  </p:cSld>
+  <p:clrMapOvr>
+    <a:masterClrMapping/>
+  </p:clrMapOvr>
+</p:notes>
+</file>
+
+<file path=ppt/notesSlides/notesSlide11.xml><?xml version="1.0" encoding="utf-8"?>
+<p:notes xmlns:a="http://schemas.openxmlformats.org/drawingml/2006/main" xmlns:r="http://schemas.openxmlformats.org/officeDocument/2006/relationships" xmlns:p="http://schemas.openxmlformats.org/presentationml/2006/main">
+  <p:cSld>
+    <p:spTree>
+      <p:nvGrpSpPr>
+        <p:cNvPr id="1" name=""/>
+        <p:cNvGrpSpPr/>
+        <p:nvPr/>
+      </p:nvGrpSpPr>
+      <p:grpSpPr>
+        <a:xfrm>
+          <a:off x="0" y="0"/>
+          <a:ext cx="0" cy="0"/>
+          <a:chOff x="0" y="0"/>
+          <a:chExt cx="0" cy="0"/>
+        </a:xfrm>
+      </p:grpSpPr>
+      <p:sp>
+        <p:nvSpPr>
+          <p:cNvPr id="2" name="Slide Image Placeholder 1"/>
+          <p:cNvSpPr>
+            <a:spLocks noGrp="1" noRot="1" noChangeAspect="1"/>
+          </p:cNvSpPr>
+          <p:nvPr>
+            <p:ph type="sldImg"/>
+          </p:nvPr>
+        </p:nvSpPr>
+        <p:spPr/>
+      </p:sp>
+      <p:sp>
+        <p:nvSpPr>
+          <p:cNvPr id="3" name="Notes Placeholder 2"/>
+          <p:cNvSpPr>
+            <a:spLocks noGrp="1"/>
+          </p:cNvSpPr>
+          <p:nvPr>
+            <p:ph type="body" idx="1"/>
+          </p:nvPr>
+        </p:nvSpPr>
+        <p:spPr/>
+        <p:txBody>
+          <a:bodyPr/>
+          <a:lstStyle/>
+          <a:p>
+            <a:r>
+              <a:rPr lang="en-US" dirty="0"/>
+              <a:t/>
+            </a:r>
+            <a:endParaRPr lang="en-US" dirty="0"/>
+          </a:p>
+        </p:txBody>
+      </p:sp>
+      <p:sp>
+        <p:nvSpPr>
+          <p:cNvPr id="4" name="Slide Number Placeholder 3"/>
+          <p:cNvSpPr>
+            <a:spLocks noGrp="1"/>
+          </p:cNvSpPr>
+          <p:nvPr>
+            <p:ph type="sldNum" sz="quarter" idx="10"/>
+          </p:nvPr>
+        </p:nvSpPr>
+        <p:spPr/>
+        <p:txBody>
+          <a:bodyPr/>
+          <a:lstStyle/>
+          <a:p>
+            <a:fld id="{F7021451-1387-4CA6-816F-3879F97B5CBC}" type="slidenum">
+              <a:rPr lang="en-US"/>
+              <a:t>11</a:t>
+            </a:fld>
+            <a:endParaRPr lang="en-US"/>
+          </a:p>
+        </p:txBody>
+      </p:sp>
+    </p:spTree>
+    <p:extLst>
+      <p:ext uri="{BB962C8B-B14F-4D97-AF65-F5344CB8AC3E}">
+        <p14:creationId xmlns:p14="http://schemas.microsoft.com/office/powerpoint/2010/main" val="1024086991"/>
+      </p:ext>
+    </p:extLst>
+  </p:cSld>
+  <p:clrMapOvr>
+    <a:masterClrMapping/>
+  </p:clrMapOvr>
+</p:notes>
+</file>
+
 <file path=ppt/notesSlides/notesSlide2.xml><?xml version="1.0" encoding="utf-8"?>
 <p:notes xmlns:a="http://schemas.openxmlformats.org/drawingml/2006/main" xmlns:r="http://schemas.openxmlformats.org/officeDocument/2006/relationships" xmlns:p="http://schemas.openxmlformats.org/presentationml/2006/main">
   <p:cSld>
@@ -1060,6 +1240,182 @@
             <a:fld id="{F7021451-1387-4CA6-816F-3879F97B5CBC}" type="slidenum">
               <a:rPr lang="en-US"/>
               <a:t>7</a:t>
+            </a:fld>
+            <a:endParaRPr lang="en-US"/>
+          </a:p>
+        </p:txBody>
+      </p:sp>
+    </p:spTree>
+    <p:extLst>
+      <p:ext uri="{BB962C8B-B14F-4D97-AF65-F5344CB8AC3E}">
+        <p14:creationId xmlns:p14="http://schemas.microsoft.com/office/powerpoint/2010/main" val="1024086991"/>
+      </p:ext>
+    </p:extLst>
+  </p:cSld>
+  <p:clrMapOvr>
+    <a:masterClrMapping/>
+  </p:clrMapOvr>
+</p:notes>
+</file>
+
+<file path=ppt/notesSlides/notesSlide8.xml><?xml version="1.0" encoding="utf-8"?>
+<p:notes xmlns:a="http://schemas.openxmlformats.org/drawingml/2006/main" xmlns:r="http://schemas.openxmlformats.org/officeDocument/2006/relationships" xmlns:p="http://schemas.openxmlformats.org/presentationml/2006/main">
+  <p:cSld>
+    <p:spTree>
+      <p:nvGrpSpPr>
+        <p:cNvPr id="1" name=""/>
+        <p:cNvGrpSpPr/>
+        <p:nvPr/>
+      </p:nvGrpSpPr>
+      <p:grpSpPr>
+        <a:xfrm>
+          <a:off x="0" y="0"/>
+          <a:ext cx="0" cy="0"/>
+          <a:chOff x="0" y="0"/>
+          <a:chExt cx="0" cy="0"/>
+        </a:xfrm>
+      </p:grpSpPr>
+      <p:sp>
+        <p:nvSpPr>
+          <p:cNvPr id="2" name="Slide Image Placeholder 1"/>
+          <p:cNvSpPr>
+            <a:spLocks noGrp="1" noRot="1" noChangeAspect="1"/>
+          </p:cNvSpPr>
+          <p:nvPr>
+            <p:ph type="sldImg"/>
+          </p:nvPr>
+        </p:nvSpPr>
+        <p:spPr/>
+      </p:sp>
+      <p:sp>
+        <p:nvSpPr>
+          <p:cNvPr id="3" name="Notes Placeholder 2"/>
+          <p:cNvSpPr>
+            <a:spLocks noGrp="1"/>
+          </p:cNvSpPr>
+          <p:nvPr>
+            <p:ph type="body" idx="1"/>
+          </p:nvPr>
+        </p:nvSpPr>
+        <p:spPr/>
+        <p:txBody>
+          <a:bodyPr/>
+          <a:lstStyle/>
+          <a:p>
+            <a:r>
+              <a:rPr lang="en-US" dirty="0"/>
+              <a:t/>
+            </a:r>
+            <a:endParaRPr lang="en-US" dirty="0"/>
+          </a:p>
+        </p:txBody>
+      </p:sp>
+      <p:sp>
+        <p:nvSpPr>
+          <p:cNvPr id="4" name="Slide Number Placeholder 3"/>
+          <p:cNvSpPr>
+            <a:spLocks noGrp="1"/>
+          </p:cNvSpPr>
+          <p:nvPr>
+            <p:ph type="sldNum" sz="quarter" idx="10"/>
+          </p:nvPr>
+        </p:nvSpPr>
+        <p:spPr/>
+        <p:txBody>
+          <a:bodyPr/>
+          <a:lstStyle/>
+          <a:p>
+            <a:fld id="{F7021451-1387-4CA6-816F-3879F97B5CBC}" type="slidenum">
+              <a:rPr lang="en-US"/>
+              <a:t>8</a:t>
+            </a:fld>
+            <a:endParaRPr lang="en-US"/>
+          </a:p>
+        </p:txBody>
+      </p:sp>
+    </p:spTree>
+    <p:extLst>
+      <p:ext uri="{BB962C8B-B14F-4D97-AF65-F5344CB8AC3E}">
+        <p14:creationId xmlns:p14="http://schemas.microsoft.com/office/powerpoint/2010/main" val="1024086991"/>
+      </p:ext>
+    </p:extLst>
+  </p:cSld>
+  <p:clrMapOvr>
+    <a:masterClrMapping/>
+  </p:clrMapOvr>
+</p:notes>
+</file>
+
+<file path=ppt/notesSlides/notesSlide9.xml><?xml version="1.0" encoding="utf-8"?>
+<p:notes xmlns:a="http://schemas.openxmlformats.org/drawingml/2006/main" xmlns:r="http://schemas.openxmlformats.org/officeDocument/2006/relationships" xmlns:p="http://schemas.openxmlformats.org/presentationml/2006/main">
+  <p:cSld>
+    <p:spTree>
+      <p:nvGrpSpPr>
+        <p:cNvPr id="1" name=""/>
+        <p:cNvGrpSpPr/>
+        <p:nvPr/>
+      </p:nvGrpSpPr>
+      <p:grpSpPr>
+        <a:xfrm>
+          <a:off x="0" y="0"/>
+          <a:ext cx="0" cy="0"/>
+          <a:chOff x="0" y="0"/>
+          <a:chExt cx="0" cy="0"/>
+        </a:xfrm>
+      </p:grpSpPr>
+      <p:sp>
+        <p:nvSpPr>
+          <p:cNvPr id="2" name="Slide Image Placeholder 1"/>
+          <p:cNvSpPr>
+            <a:spLocks noGrp="1" noRot="1" noChangeAspect="1"/>
+          </p:cNvSpPr>
+          <p:nvPr>
+            <p:ph type="sldImg"/>
+          </p:nvPr>
+        </p:nvSpPr>
+        <p:spPr/>
+      </p:sp>
+      <p:sp>
+        <p:nvSpPr>
+          <p:cNvPr id="3" name="Notes Placeholder 2"/>
+          <p:cNvSpPr>
+            <a:spLocks noGrp="1"/>
+          </p:cNvSpPr>
+          <p:nvPr>
+            <p:ph type="body" idx="1"/>
+          </p:nvPr>
+        </p:nvSpPr>
+        <p:spPr/>
+        <p:txBody>
+          <a:bodyPr/>
+          <a:lstStyle/>
+          <a:p>
+            <a:r>
+              <a:rPr lang="en-US" dirty="0"/>
+              <a:t/>
+            </a:r>
+            <a:endParaRPr lang="en-US" dirty="0"/>
+          </a:p>
+        </p:txBody>
+      </p:sp>
+      <p:sp>
+        <p:nvSpPr>
+          <p:cNvPr id="4" name="Slide Number Placeholder 3"/>
+          <p:cNvSpPr>
+            <a:spLocks noGrp="1"/>
+          </p:cNvSpPr>
+          <p:nvPr>
+            <p:ph type="sldNum" sz="quarter" idx="10"/>
+          </p:nvPr>
+        </p:nvSpPr>
+        <p:spPr/>
+        <p:txBody>
+          <a:bodyPr/>
+          <a:lstStyle/>
+          <a:p>
+            <a:fld id="{F7021451-1387-4CA6-816F-3879F97B5CBC}" type="slidenum">
+              <a:rPr lang="en-US"/>
+              <a:t>9</a:t>
             </a:fld>
             <a:endParaRPr lang="en-US"/>
           </a:p>
@@ -1642,6 +1998,274 @@
 </p:sld>
 </file>
 
+<file path=ppt/slides/slide10.xml><?xml version="1.0" encoding="utf-8"?>
+<p:sld xmlns:a="http://schemas.openxmlformats.org/drawingml/2006/main" xmlns:r="http://schemas.openxmlformats.org/officeDocument/2006/relationships" xmlns:p="http://schemas.openxmlformats.org/presentationml/2006/main">
+  <p:cSld name="Slide 10">
+    <p:bg>
+      <p:bgPr>
+        <a:solidFill>
+          <a:srgbClr val="FFFFFF"/>
+        </a:solidFill>
+      </p:bgPr>
+    </p:bg>
+    <p:spTree>
+      <p:nvGrpSpPr>
+        <p:cNvPr id="1" name=""/>
+        <p:cNvGrpSpPr/>
+        <p:nvPr/>
+      </p:nvGrpSpPr>
+      <p:grpSpPr>
+        <a:xfrm>
+          <a:off x="0" y="0"/>
+          <a:ext cx="0" cy="0"/>
+          <a:chOff x="0" y="0"/>
+          <a:chExt cx="0" cy="0"/>
+        </a:xfrm>
+      </p:grpSpPr>
+      <p:sp>
+        <p:nvSpPr>
+          <p:cNvPr id="2" name="Text 0"/>
+          <p:cNvSpPr txBox="1"/>
+          <p:nvPr/>
+        </p:nvSpPr>
+        <p:spPr>
+          <a:xfrm>
+            <a:off x="914400" y="0"/>
+            <a:ext cx="10360152" cy="6858000"/>
+          </a:xfrm>
+          <a:prstGeom prst="rect">
+            <a:avLst/>
+          </a:prstGeom>
+          <a:noFill/>
+          <a:ln/>
+        </p:spPr>
+        <p:txBody>
+          <a:bodyPr wrap="square" lIns="0" tIns="0" rIns="0" bIns="0" rtlCol="0" anchor="ctr"/>
+          <a:lstStyle/>
+          <a:p>
+            <a:pPr algn="ctr" indent="0" marL="0">
+              <a:buNone/>
+            </a:pPr>
+            <a:r>
+              <a:rPr lang="en-US" sz="4000" b="1" dirty="0">
+                <a:solidFill>
+                  <a:srgbClr val="1F4E96"/>
+                </a:solidFill>
+                <a:latin typeface="Cambria" pitchFamily="34" charset="0"/>
+                <a:ea typeface="Cambria" pitchFamily="34" charset="-122"/>
+                <a:cs typeface="Cambria" pitchFamily="34" charset="-120"/>
+              </a:rPr>
+              <a:t>12. Should you stay or should you go?</a:t>
+            </a:r>
+            <a:endParaRPr lang="en-US" sz="4000" dirty="0"/>
+          </a:p>
+        </p:txBody>
+      </p:sp>
+      <p:pic>
+        <p:nvPicPr>
+          <p:cNvPr id="3" name="Image 0" descr="book-cover.png">    </p:cNvPr>
+          <p:cNvPicPr>
+            <a:picLocks noChangeAspect="1"/>
+          </p:cNvPicPr>
+          <p:nvPr/>
+        </p:nvPicPr>
+        <p:blipFill>
+          <a:blip r:embed="rId1"/>
+          <a:stretch>
+            <a:fillRect/>
+          </a:stretch>
+        </p:blipFill>
+        <p:spPr>
+          <a:xfrm>
+            <a:off x="457200" y="4599552"/>
+            <a:ext cx="1188720" cy="1801248"/>
+          </a:xfrm>
+          <a:prstGeom prst="rect">
+            <a:avLst/>
+          </a:prstGeom>
+        </p:spPr>
+      </p:pic>
+      <p:sp>
+        <p:nvSpPr>
+          <p:cNvPr id="4" name="Text 1"/>
+          <p:cNvSpPr txBox="1"/>
+          <p:nvPr/>
+        </p:nvSpPr>
+        <p:spPr>
+          <a:xfrm>
+            <a:off x="8076895" y="6263640"/>
+            <a:ext cx="3657600" cy="320040"/>
+          </a:xfrm>
+          <a:prstGeom prst="rect">
+            <a:avLst/>
+          </a:prstGeom>
+          <a:noFill/>
+          <a:ln/>
+        </p:spPr>
+        <p:txBody>
+          <a:bodyPr wrap="square" lIns="0" tIns="0" rIns="0" bIns="0" rtlCol="0" anchor="b"/>
+          <a:lstStyle/>
+          <a:p>
+            <a:pPr algn="r" indent="0" marL="0">
+              <a:buNone/>
+            </a:pPr>
+            <a:r>
+              <a:rPr lang="en-US" sz="1100" i="1" dirty="0">
+                <a:solidFill>
+                  <a:srgbClr val="7A7A7A"/>
+                </a:solidFill>
+                <a:latin typeface="Calibri" pitchFamily="34" charset="0"/>
+                <a:ea typeface="Calibri" pitchFamily="34" charset="-122"/>
+                <a:cs typeface="Calibri" pitchFamily="34" charset="-120"/>
+              </a:rPr>
+              <a:t>Delivering the Impossible — Mark Stringer</a:t>
+            </a:r>
+            <a:endParaRPr lang="en-US" sz="1100" dirty="0"/>
+          </a:p>
+        </p:txBody>
+      </p:sp>
+    </p:spTree>
+  </p:cSld>
+  <p:clrMapOvr>
+    <a:masterClrMapping/>
+  </p:clrMapOvr>
+</p:sld>
+</file>
+
+<file path=ppt/slides/slide11.xml><?xml version="1.0" encoding="utf-8"?>
+<p:sld xmlns:a="http://schemas.openxmlformats.org/drawingml/2006/main" xmlns:r="http://schemas.openxmlformats.org/officeDocument/2006/relationships" xmlns:p="http://schemas.openxmlformats.org/presentationml/2006/main">
+  <p:cSld name="Slide 11">
+    <p:bg>
+      <p:bgPr>
+        <a:solidFill>
+          <a:srgbClr val="FFFFFF"/>
+        </a:solidFill>
+      </p:bgPr>
+    </p:bg>
+    <p:spTree>
+      <p:nvGrpSpPr>
+        <p:cNvPr id="1" name=""/>
+        <p:cNvGrpSpPr/>
+        <p:nvPr/>
+      </p:nvGrpSpPr>
+      <p:grpSpPr>
+        <a:xfrm>
+          <a:off x="0" y="0"/>
+          <a:ext cx="0" cy="0"/>
+          <a:chOff x="0" y="0"/>
+          <a:chExt cx="0" cy="0"/>
+        </a:xfrm>
+      </p:grpSpPr>
+      <p:sp>
+        <p:nvSpPr>
+          <p:cNvPr id="2" name="Text 0"/>
+          <p:cNvSpPr txBox="1"/>
+          <p:nvPr/>
+        </p:nvSpPr>
+        <p:spPr>
+          <a:xfrm>
+            <a:off x="914400" y="0"/>
+            <a:ext cx="10360152" cy="6858000"/>
+          </a:xfrm>
+          <a:prstGeom prst="rect">
+            <a:avLst/>
+          </a:prstGeom>
+          <a:noFill/>
+          <a:ln/>
+        </p:spPr>
+        <p:txBody>
+          <a:bodyPr wrap="square" lIns="0" tIns="0" rIns="0" bIns="0" rtlCol="0" anchor="ctr"/>
+          <a:lstStyle/>
+          <a:p>
+            <a:pPr algn="ctr" indent="0" marL="0">
+              <a:buNone/>
+            </a:pPr>
+            <a:r>
+              <a:rPr lang="en-US" sz="4000" b="1" dirty="0">
+                <a:solidFill>
+                  <a:srgbClr val="1F4E96"/>
+                </a:solidFill>
+                <a:latin typeface="Cambria" pitchFamily="34" charset="0"/>
+                <a:ea typeface="Cambria" pitchFamily="34" charset="-122"/>
+                <a:cs typeface="Cambria" pitchFamily="34" charset="-120"/>
+              </a:rPr>
+              <a:t>13. Looking glass poker</a:t>
+            </a:r>
+            <a:endParaRPr lang="en-US" sz="4000" dirty="0"/>
+          </a:p>
+        </p:txBody>
+      </p:sp>
+      <p:pic>
+        <p:nvPicPr>
+          <p:cNvPr id="3" name="Image 0" descr="book-cover.png">    </p:cNvPr>
+          <p:cNvPicPr>
+            <a:picLocks noChangeAspect="1"/>
+          </p:cNvPicPr>
+          <p:nvPr/>
+        </p:nvPicPr>
+        <p:blipFill>
+          <a:blip r:embed="rId1"/>
+          <a:stretch>
+            <a:fillRect/>
+          </a:stretch>
+        </p:blipFill>
+        <p:spPr>
+          <a:xfrm>
+            <a:off x="457200" y="4599552"/>
+            <a:ext cx="1188720" cy="1801248"/>
+          </a:xfrm>
+          <a:prstGeom prst="rect">
+            <a:avLst/>
+          </a:prstGeom>
+        </p:spPr>
+      </p:pic>
+      <p:sp>
+        <p:nvSpPr>
+          <p:cNvPr id="4" name="Text 1"/>
+          <p:cNvSpPr txBox="1"/>
+          <p:nvPr/>
+        </p:nvSpPr>
+        <p:spPr>
+          <a:xfrm>
+            <a:off x="8076895" y="6263640"/>
+            <a:ext cx="3657600" cy="320040"/>
+          </a:xfrm>
+          <a:prstGeom prst="rect">
+            <a:avLst/>
+          </a:prstGeom>
+          <a:noFill/>
+          <a:ln/>
+        </p:spPr>
+        <p:txBody>
+          <a:bodyPr wrap="square" lIns="0" tIns="0" rIns="0" bIns="0" rtlCol="0" anchor="b"/>
+          <a:lstStyle/>
+          <a:p>
+            <a:pPr algn="r" indent="0" marL="0">
+              <a:buNone/>
+            </a:pPr>
+            <a:r>
+              <a:rPr lang="en-US" sz="1100" i="1" dirty="0">
+                <a:solidFill>
+                  <a:srgbClr val="7A7A7A"/>
+                </a:solidFill>
+                <a:latin typeface="Calibri" pitchFamily="34" charset="0"/>
+                <a:ea typeface="Calibri" pitchFamily="34" charset="-122"/>
+                <a:cs typeface="Calibri" pitchFamily="34" charset="-120"/>
+              </a:rPr>
+              <a:t>Delivering the Impossible — Mark Stringer</a:t>
+            </a:r>
+            <a:endParaRPr lang="en-US" sz="1100" dirty="0"/>
+          </a:p>
+        </p:txBody>
+      </p:sp>
+    </p:spTree>
+  </p:cSld>
+  <p:clrMapOvr>
+    <a:masterClrMapping/>
+  </p:clrMapOvr>
+</p:sld>
+</file>
+
 <file path=ppt/slides/slide2.xml><?xml version="1.0" encoding="utf-8"?>
 <p:sld xmlns:a="http://schemas.openxmlformats.org/drawingml/2006/main" xmlns:r="http://schemas.openxmlformats.org/officeDocument/2006/relationships" xmlns:p="http://schemas.openxmlformats.org/presentationml/2006/main">
   <p:cSld name="Slide 2">
@@ -2494,6 +3118,274 @@
                 <a:cs typeface="Cambria" pitchFamily="34" charset="-120"/>
               </a:rPr>
               <a:t>9. The Archbishop of Canterbury and nonsense accumulators</a:t>
+            </a:r>
+            <a:endParaRPr lang="en-US" sz="4000" dirty="0"/>
+          </a:p>
+        </p:txBody>
+      </p:sp>
+      <p:pic>
+        <p:nvPicPr>
+          <p:cNvPr id="3" name="Image 0" descr="book-cover.png">    </p:cNvPr>
+          <p:cNvPicPr>
+            <a:picLocks noChangeAspect="1"/>
+          </p:cNvPicPr>
+          <p:nvPr/>
+        </p:nvPicPr>
+        <p:blipFill>
+          <a:blip r:embed="rId1"/>
+          <a:stretch>
+            <a:fillRect/>
+          </a:stretch>
+        </p:blipFill>
+        <p:spPr>
+          <a:xfrm>
+            <a:off x="457200" y="4599552"/>
+            <a:ext cx="1188720" cy="1801248"/>
+          </a:xfrm>
+          <a:prstGeom prst="rect">
+            <a:avLst/>
+          </a:prstGeom>
+        </p:spPr>
+      </p:pic>
+      <p:sp>
+        <p:nvSpPr>
+          <p:cNvPr id="4" name="Text 1"/>
+          <p:cNvSpPr txBox="1"/>
+          <p:nvPr/>
+        </p:nvSpPr>
+        <p:spPr>
+          <a:xfrm>
+            <a:off x="8076895" y="6263640"/>
+            <a:ext cx="3657600" cy="320040"/>
+          </a:xfrm>
+          <a:prstGeom prst="rect">
+            <a:avLst/>
+          </a:prstGeom>
+          <a:noFill/>
+          <a:ln/>
+        </p:spPr>
+        <p:txBody>
+          <a:bodyPr wrap="square" lIns="0" tIns="0" rIns="0" bIns="0" rtlCol="0" anchor="b"/>
+          <a:lstStyle/>
+          <a:p>
+            <a:pPr algn="r" indent="0" marL="0">
+              <a:buNone/>
+            </a:pPr>
+            <a:r>
+              <a:rPr lang="en-US" sz="1100" i="1" dirty="0">
+                <a:solidFill>
+                  <a:srgbClr val="7A7A7A"/>
+                </a:solidFill>
+                <a:latin typeface="Calibri" pitchFamily="34" charset="0"/>
+                <a:ea typeface="Calibri" pitchFamily="34" charset="-122"/>
+                <a:cs typeface="Calibri" pitchFamily="34" charset="-120"/>
+              </a:rPr>
+              <a:t>Delivering the Impossible — Mark Stringer</a:t>
+            </a:r>
+            <a:endParaRPr lang="en-US" sz="1100" dirty="0"/>
+          </a:p>
+        </p:txBody>
+      </p:sp>
+    </p:spTree>
+  </p:cSld>
+  <p:clrMapOvr>
+    <a:masterClrMapping/>
+  </p:clrMapOvr>
+</p:sld>
+</file>
+
+<file path=ppt/slides/slide8.xml><?xml version="1.0" encoding="utf-8"?>
+<p:sld xmlns:a="http://schemas.openxmlformats.org/drawingml/2006/main" xmlns:r="http://schemas.openxmlformats.org/officeDocument/2006/relationships" xmlns:p="http://schemas.openxmlformats.org/presentationml/2006/main">
+  <p:cSld name="Slide 8">
+    <p:bg>
+      <p:bgPr>
+        <a:solidFill>
+          <a:srgbClr val="FFFFFF"/>
+        </a:solidFill>
+      </p:bgPr>
+    </p:bg>
+    <p:spTree>
+      <p:nvGrpSpPr>
+        <p:cNvPr id="1" name=""/>
+        <p:cNvGrpSpPr/>
+        <p:nvPr/>
+      </p:nvGrpSpPr>
+      <p:grpSpPr>
+        <a:xfrm>
+          <a:off x="0" y="0"/>
+          <a:ext cx="0" cy="0"/>
+          <a:chOff x="0" y="0"/>
+          <a:chExt cx="0" cy="0"/>
+        </a:xfrm>
+      </p:grpSpPr>
+      <p:sp>
+        <p:nvSpPr>
+          <p:cNvPr id="2" name="Text 0"/>
+          <p:cNvSpPr txBox="1"/>
+          <p:nvPr/>
+        </p:nvSpPr>
+        <p:spPr>
+          <a:xfrm>
+            <a:off x="914400" y="0"/>
+            <a:ext cx="10360152" cy="6858000"/>
+          </a:xfrm>
+          <a:prstGeom prst="rect">
+            <a:avLst/>
+          </a:prstGeom>
+          <a:noFill/>
+          <a:ln/>
+        </p:spPr>
+        <p:txBody>
+          <a:bodyPr wrap="square" lIns="0" tIns="0" rIns="0" bIns="0" rtlCol="0" anchor="ctr"/>
+          <a:lstStyle/>
+          <a:p>
+            <a:pPr algn="ctr" indent="0" marL="0">
+              <a:buNone/>
+            </a:pPr>
+            <a:r>
+              <a:rPr lang="en-US" sz="4000" b="1" dirty="0">
+                <a:solidFill>
+                  <a:srgbClr val="1F4E96"/>
+                </a:solidFill>
+                <a:latin typeface="Cambria" pitchFamily="34" charset="0"/>
+                <a:ea typeface="Cambria" pitchFamily="34" charset="-122"/>
+                <a:cs typeface="Cambria" pitchFamily="34" charset="-120"/>
+              </a:rPr>
+              <a:t>10. Bricks without straw</a:t>
+            </a:r>
+            <a:endParaRPr lang="en-US" sz="4000" dirty="0"/>
+          </a:p>
+        </p:txBody>
+      </p:sp>
+      <p:pic>
+        <p:nvPicPr>
+          <p:cNvPr id="3" name="Image 0" descr="book-cover.png">    </p:cNvPr>
+          <p:cNvPicPr>
+            <a:picLocks noChangeAspect="1"/>
+          </p:cNvPicPr>
+          <p:nvPr/>
+        </p:nvPicPr>
+        <p:blipFill>
+          <a:blip r:embed="rId1"/>
+          <a:stretch>
+            <a:fillRect/>
+          </a:stretch>
+        </p:blipFill>
+        <p:spPr>
+          <a:xfrm>
+            <a:off x="457200" y="4599552"/>
+            <a:ext cx="1188720" cy="1801248"/>
+          </a:xfrm>
+          <a:prstGeom prst="rect">
+            <a:avLst/>
+          </a:prstGeom>
+        </p:spPr>
+      </p:pic>
+      <p:sp>
+        <p:nvSpPr>
+          <p:cNvPr id="4" name="Text 1"/>
+          <p:cNvSpPr txBox="1"/>
+          <p:nvPr/>
+        </p:nvSpPr>
+        <p:spPr>
+          <a:xfrm>
+            <a:off x="8076895" y="6263640"/>
+            <a:ext cx="3657600" cy="320040"/>
+          </a:xfrm>
+          <a:prstGeom prst="rect">
+            <a:avLst/>
+          </a:prstGeom>
+          <a:noFill/>
+          <a:ln/>
+        </p:spPr>
+        <p:txBody>
+          <a:bodyPr wrap="square" lIns="0" tIns="0" rIns="0" bIns="0" rtlCol="0" anchor="b"/>
+          <a:lstStyle/>
+          <a:p>
+            <a:pPr algn="r" indent="0" marL="0">
+              <a:buNone/>
+            </a:pPr>
+            <a:r>
+              <a:rPr lang="en-US" sz="1100" i="1" dirty="0">
+                <a:solidFill>
+                  <a:srgbClr val="7A7A7A"/>
+                </a:solidFill>
+                <a:latin typeface="Calibri" pitchFamily="34" charset="0"/>
+                <a:ea typeface="Calibri" pitchFamily="34" charset="-122"/>
+                <a:cs typeface="Calibri" pitchFamily="34" charset="-120"/>
+              </a:rPr>
+              <a:t>Delivering the Impossible — Mark Stringer</a:t>
+            </a:r>
+            <a:endParaRPr lang="en-US" sz="1100" dirty="0"/>
+          </a:p>
+        </p:txBody>
+      </p:sp>
+    </p:spTree>
+  </p:cSld>
+  <p:clrMapOvr>
+    <a:masterClrMapping/>
+  </p:clrMapOvr>
+</p:sld>
+</file>
+
+<file path=ppt/slides/slide9.xml><?xml version="1.0" encoding="utf-8"?>
+<p:sld xmlns:a="http://schemas.openxmlformats.org/drawingml/2006/main" xmlns:r="http://schemas.openxmlformats.org/officeDocument/2006/relationships" xmlns:p="http://schemas.openxmlformats.org/presentationml/2006/main">
+  <p:cSld name="Slide 9">
+    <p:bg>
+      <p:bgPr>
+        <a:solidFill>
+          <a:srgbClr val="FFFFFF"/>
+        </a:solidFill>
+      </p:bgPr>
+    </p:bg>
+    <p:spTree>
+      <p:nvGrpSpPr>
+        <p:cNvPr id="1" name=""/>
+        <p:cNvGrpSpPr/>
+        <p:nvPr/>
+      </p:nvGrpSpPr>
+      <p:grpSpPr>
+        <a:xfrm>
+          <a:off x="0" y="0"/>
+          <a:ext cx="0" cy="0"/>
+          <a:chOff x="0" y="0"/>
+          <a:chExt cx="0" cy="0"/>
+        </a:xfrm>
+      </p:grpSpPr>
+      <p:sp>
+        <p:nvSpPr>
+          <p:cNvPr id="2" name="Text 0"/>
+          <p:cNvSpPr txBox="1"/>
+          <p:nvPr/>
+        </p:nvSpPr>
+        <p:spPr>
+          <a:xfrm>
+            <a:off x="914400" y="0"/>
+            <a:ext cx="10360152" cy="6858000"/>
+          </a:xfrm>
+          <a:prstGeom prst="rect">
+            <a:avLst/>
+          </a:prstGeom>
+          <a:noFill/>
+          <a:ln/>
+        </p:spPr>
+        <p:txBody>
+          <a:bodyPr wrap="square" lIns="0" tIns="0" rIns="0" bIns="0" rtlCol="0" anchor="ctr"/>
+          <a:lstStyle/>
+          <a:p>
+            <a:pPr algn="ctr" indent="0" marL="0">
+              <a:buNone/>
+            </a:pPr>
+            <a:r>
+              <a:rPr lang="en-US" sz="4000" b="1" dirty="0">
+                <a:solidFill>
+                  <a:srgbClr val="1F4E96"/>
+                </a:solidFill>
+                <a:latin typeface="Cambria" pitchFamily="34" charset="0"/>
+                <a:ea typeface="Cambria" pitchFamily="34" charset="-122"/>
+                <a:cs typeface="Cambria" pitchFamily="34" charset="-120"/>
+              </a:rPr>
+              <a:t>11. The baby seal and the big bad dog</a:t>
             </a:r>
             <a:endParaRPr lang="en-US" sz="4000" dirty="0"/>
           </a:p>

</xml_diff>

<commit_message>
Finalize deck: title, subtitle, strip numbering, closing slide
- Slide 1 title: "All projects are bets - except the ones that aren't";
  subtitle set to "Mark Stringer"; layout re-spaced to fit the two-line
  title without colliding with the subtitle.
- Removed the leading numbers from all section-header slide titles.
- Added a closing slide: full-bleed cover on the left, email address
  mark.stringer@gmail.com on the right, mirroring slide 1's layout.

Co-Authored-By: Claude Sonnet 5 <noreply@anthropic.com>
</commit_message>
<xml_diff>
--- a/templates/book-cover-slide-template.pptx
+++ b/templates/book-cover-slide-template.pptx
@@ -16,9 +16,10 @@
     <p:sldId id="264" r:id="rId10"/>
     <p:sldId id="265" r:id="rId11"/>
     <p:sldId id="266" r:id="rId12"/>
+    <p:sldId id="267" r:id="rId13"/>
   </p:sldIdLst>
   <p:notesMasterIdLst>
-    <p:notesMasterId r:id="rId13"/>
+    <p:notesMasterId r:id="rId14"/>
   </p:notesMasterIdLst>
   <p:sldSz cx="12192000" cy="6858000"/>
   <p:notesSz cx="6858000" cy="12192000"/>
@@ -712,6 +713,94 @@
             <a:fld id="{F7021451-1387-4CA6-816F-3879F97B5CBC}" type="slidenum">
               <a:rPr lang="en-US"/>
               <a:t>11</a:t>
+            </a:fld>
+            <a:endParaRPr lang="en-US"/>
+          </a:p>
+        </p:txBody>
+      </p:sp>
+    </p:spTree>
+    <p:extLst>
+      <p:ext uri="{BB962C8B-B14F-4D97-AF65-F5344CB8AC3E}">
+        <p14:creationId xmlns:p14="http://schemas.microsoft.com/office/powerpoint/2010/main" val="1024086991"/>
+      </p:ext>
+    </p:extLst>
+  </p:cSld>
+  <p:clrMapOvr>
+    <a:masterClrMapping/>
+  </p:clrMapOvr>
+</p:notes>
+</file>
+
+<file path=ppt/notesSlides/notesSlide12.xml><?xml version="1.0" encoding="utf-8"?>
+<p:notes xmlns:a="http://schemas.openxmlformats.org/drawingml/2006/main" xmlns:r="http://schemas.openxmlformats.org/officeDocument/2006/relationships" xmlns:p="http://schemas.openxmlformats.org/presentationml/2006/main">
+  <p:cSld>
+    <p:spTree>
+      <p:nvGrpSpPr>
+        <p:cNvPr id="1" name=""/>
+        <p:cNvGrpSpPr/>
+        <p:nvPr/>
+      </p:nvGrpSpPr>
+      <p:grpSpPr>
+        <a:xfrm>
+          <a:off x="0" y="0"/>
+          <a:ext cx="0" cy="0"/>
+          <a:chOff x="0" y="0"/>
+          <a:chExt cx="0" cy="0"/>
+        </a:xfrm>
+      </p:grpSpPr>
+      <p:sp>
+        <p:nvSpPr>
+          <p:cNvPr id="2" name="Slide Image Placeholder 1"/>
+          <p:cNvSpPr>
+            <a:spLocks noGrp="1" noRot="1" noChangeAspect="1"/>
+          </p:cNvSpPr>
+          <p:nvPr>
+            <p:ph type="sldImg"/>
+          </p:nvPr>
+        </p:nvSpPr>
+        <p:spPr/>
+      </p:sp>
+      <p:sp>
+        <p:nvSpPr>
+          <p:cNvPr id="3" name="Notes Placeholder 2"/>
+          <p:cNvSpPr>
+            <a:spLocks noGrp="1"/>
+          </p:cNvSpPr>
+          <p:nvPr>
+            <p:ph type="body" idx="1"/>
+          </p:nvPr>
+        </p:nvSpPr>
+        <p:spPr/>
+        <p:txBody>
+          <a:bodyPr/>
+          <a:lstStyle/>
+          <a:p>
+            <a:r>
+              <a:rPr lang="en-US" dirty="0"/>
+              <a:t/>
+            </a:r>
+            <a:endParaRPr lang="en-US" dirty="0"/>
+          </a:p>
+        </p:txBody>
+      </p:sp>
+      <p:sp>
+        <p:nvSpPr>
+          <p:cNvPr id="4" name="Slide Number Placeholder 3"/>
+          <p:cNvSpPr>
+            <a:spLocks noGrp="1"/>
+          </p:cNvSpPr>
+          <p:nvPr>
+            <p:ph type="sldNum" sz="quarter" idx="10"/>
+          </p:nvPr>
+        </p:nvSpPr>
+        <p:spPr/>
+        <p:txBody>
+          <a:bodyPr/>
+          <a:lstStyle/>
+          <a:p>
+            <a:fld id="{F7021451-1387-4CA6-816F-3879F97B5CBC}" type="slidenum">
+              <a:rPr lang="en-US"/>
+              <a:t>12</a:t>
             </a:fld>
             <a:endParaRPr lang="en-US"/>
           </a:p>
@@ -1796,8 +1885,8 @@
         </p:nvSpPr>
         <p:spPr>
           <a:xfrm>
-            <a:off x="5806440" y="548640"/>
-            <a:ext cx="5928055" cy="1005840"/>
+            <a:off x="5806440" y="457200"/>
+            <a:ext cx="5928055" cy="1645920"/>
           </a:xfrm>
           <a:prstGeom prst="rect">
             <a:avLst/>
@@ -1821,7 +1910,7 @@
                 <a:ea typeface="Cambria" pitchFamily="34" charset="-122"/>
                 <a:cs typeface="Cambria" pitchFamily="34" charset="-120"/>
               </a:rPr>
-              <a:t>Click to add title</a:t>
+              <a:t>All projects are bets - except the ones that aren't</a:t>
             </a:r>
             <a:endParaRPr lang="en-US" sz="3600" dirty="0"/>
           </a:p>
@@ -1835,7 +1924,7 @@
         </p:nvSpPr>
         <p:spPr>
           <a:xfrm>
-            <a:off x="5806440" y="1508760"/>
+            <a:off x="5806440" y="2148840"/>
             <a:ext cx="5928055" cy="457200"/>
           </a:xfrm>
           <a:prstGeom prst="rect">
@@ -1860,7 +1949,7 @@
                 <a:ea typeface="Calibri" pitchFamily="34" charset="-122"/>
                 <a:cs typeface="Calibri" pitchFamily="34" charset="-120"/>
               </a:rPr>
-              <a:t>Click to add subtitle</a:t>
+              <a:t>Mark Stringer</a:t>
             </a:r>
             <a:endParaRPr lang="en-US" sz="1800" dirty="0"/>
           </a:p>
@@ -1874,8 +1963,8 @@
         </p:nvSpPr>
         <p:spPr>
           <a:xfrm>
-            <a:off x="5806440" y="2286000"/>
-            <a:ext cx="5928055" cy="3566160"/>
+            <a:off x="5806440" y="2926080"/>
+            <a:ext cx="5928055" cy="2926080"/>
           </a:xfrm>
           <a:prstGeom prst="rect">
             <a:avLst/>
@@ -2055,7 +2144,7 @@
                 <a:ea typeface="Cambria" pitchFamily="34" charset="-122"/>
                 <a:cs typeface="Cambria" pitchFamily="34" charset="-120"/>
               </a:rPr>
-              <a:t>12. Should you stay or should you go?</a:t>
+              <a:t>Should you stay or should you go?</a:t>
             </a:r>
             <a:endParaRPr lang="en-US" sz="4000" dirty="0"/>
           </a:p>
@@ -2189,7 +2278,7 @@
                 <a:ea typeface="Cambria" pitchFamily="34" charset="-122"/>
                 <a:cs typeface="Cambria" pitchFamily="34" charset="-120"/>
               </a:rPr>
-              <a:t>13. Looking glass poker</a:t>
+              <a:t>Looking glass poker</a:t>
             </a:r>
             <a:endParaRPr lang="en-US" sz="4000" dirty="0"/>
           </a:p>
@@ -2255,6 +2344,100 @@
               <a:t>Delivering the Impossible — Mark Stringer</a:t>
             </a:r>
             <a:endParaRPr lang="en-US" sz="1100" dirty="0"/>
+          </a:p>
+        </p:txBody>
+      </p:sp>
+    </p:spTree>
+  </p:cSld>
+  <p:clrMapOvr>
+    <a:masterClrMapping/>
+  </p:clrMapOvr>
+</p:sld>
+</file>
+
+<file path=ppt/slides/slide12.xml><?xml version="1.0" encoding="utf-8"?>
+<p:sld xmlns:a="http://schemas.openxmlformats.org/drawingml/2006/main" xmlns:r="http://schemas.openxmlformats.org/officeDocument/2006/relationships" xmlns:p="http://schemas.openxmlformats.org/presentationml/2006/main">
+  <p:cSld name="Slide 12">
+    <p:bg>
+      <p:bgPr>
+        <a:solidFill>
+          <a:srgbClr val="FFFFFF"/>
+        </a:solidFill>
+      </p:bgPr>
+    </p:bg>
+    <p:spTree>
+      <p:nvGrpSpPr>
+        <p:cNvPr id="1" name=""/>
+        <p:cNvGrpSpPr/>
+        <p:nvPr/>
+      </p:nvGrpSpPr>
+      <p:grpSpPr>
+        <a:xfrm>
+          <a:off x="0" y="0"/>
+          <a:ext cx="0" cy="0"/>
+          <a:chOff x="0" y="0"/>
+          <a:chExt cx="0" cy="0"/>
+        </a:xfrm>
+      </p:grpSpPr>
+      <p:pic>
+        <p:nvPicPr>
+          <p:cNvPr id="2" name="Image 0" descr="book-cover.png">    </p:cNvPr>
+          <p:cNvPicPr>
+            <a:picLocks noChangeAspect="1"/>
+          </p:cNvPicPr>
+          <p:nvPr/>
+        </p:nvPicPr>
+        <p:blipFill>
+          <a:blip r:embed="rId1"/>
+          <a:srcRect l="0" r="0" t="0" b="0"/>
+          <a:stretch/>
+        </p:blipFill>
+        <p:spPr>
+          <a:xfrm>
+            <a:off x="0" y="0"/>
+            <a:ext cx="5166360" cy="6858000"/>
+          </a:xfrm>
+          <a:prstGeom prst="rect">
+            <a:avLst/>
+          </a:prstGeom>
+        </p:spPr>
+      </p:pic>
+      <p:sp>
+        <p:nvSpPr>
+          <p:cNvPr id="3" name="Text 0"/>
+          <p:cNvSpPr txBox="1"/>
+          <p:nvPr/>
+        </p:nvSpPr>
+        <p:spPr>
+          <a:xfrm>
+            <a:off x="5806440" y="0"/>
+            <a:ext cx="5928055" cy="6858000"/>
+          </a:xfrm>
+          <a:prstGeom prst="rect">
+            <a:avLst/>
+          </a:prstGeom>
+          <a:noFill/>
+          <a:ln/>
+        </p:spPr>
+        <p:txBody>
+          <a:bodyPr wrap="square" lIns="0" tIns="0" rIns="0" bIns="0" rtlCol="0" anchor="ctr"/>
+          <a:lstStyle/>
+          <a:p>
+            <a:pPr algn="l" indent="0" marL="0">
+              <a:buNone/>
+            </a:pPr>
+            <a:r>
+              <a:rPr lang="en-US" sz="2800" b="1" dirty="0">
+                <a:solidFill>
+                  <a:srgbClr val="1F4E96"/>
+                </a:solidFill>
+                <a:latin typeface="Cambria" pitchFamily="34" charset="0"/>
+                <a:ea typeface="Cambria" pitchFamily="34" charset="-122"/>
+                <a:cs typeface="Cambria" pitchFamily="34" charset="-120"/>
+              </a:rPr>
+              <a:t>mark.stringer@gmail.com</a:t>
+            </a:r>
+            <a:endParaRPr lang="en-US" sz="2800" dirty="0"/>
           </a:p>
         </p:txBody>
       </p:sp>
@@ -2581,7 +2764,7 @@
                 <a:ea typeface="Cambria" pitchFamily="34" charset="-122"/>
                 <a:cs typeface="Cambria" pitchFamily="34" charset="-120"/>
               </a:rPr>
-              <a:t>4. project management theatre</a:t>
+              <a:t>project management theatre</a:t>
             </a:r>
             <a:endParaRPr lang="en-US" sz="4000" dirty="0"/>
           </a:p>
@@ -2715,7 +2898,7 @@
                 <a:ea typeface="Cambria" pitchFamily="34" charset="-122"/>
                 <a:cs typeface="Cambria" pitchFamily="34" charset="-120"/>
               </a:rPr>
-              <a:t>6. Shortening the odds:  making smaller bets, cheating</a:t>
+              <a:t>Shortening the odds:  making smaller bets, cheating</a:t>
             </a:r>
             <a:endParaRPr lang="en-US" sz="4000" dirty="0"/>
           </a:p>
@@ -2849,7 +3032,7 @@
                 <a:ea typeface="Cambria" pitchFamily="34" charset="-122"/>
                 <a:cs typeface="Cambria" pitchFamily="34" charset="-120"/>
               </a:rPr>
-              <a:t>7. Upping the bet</a:t>
+              <a:t>Upping the bet</a:t>
             </a:r>
             <a:endParaRPr lang="en-US" sz="4000" dirty="0"/>
           </a:p>
@@ -2983,7 +3166,7 @@
                 <a:ea typeface="Cambria" pitchFamily="34" charset="-122"/>
                 <a:cs typeface="Cambria" pitchFamily="34" charset="-120"/>
               </a:rPr>
-              <a:t>8. Some things aren't bets</a:t>
+              <a:t>Some things aren't bets</a:t>
             </a:r>
             <a:endParaRPr lang="en-US" sz="4000" dirty="0"/>
           </a:p>
@@ -3117,7 +3300,7 @@
                 <a:ea typeface="Cambria" pitchFamily="34" charset="-122"/>
                 <a:cs typeface="Cambria" pitchFamily="34" charset="-120"/>
               </a:rPr>
-              <a:t>9. The Archbishop of Canterbury and nonsense accumulators</a:t>
+              <a:t>The Archbishop of Canterbury and nonsense accumulators</a:t>
             </a:r>
             <a:endParaRPr lang="en-US" sz="4000" dirty="0"/>
           </a:p>
@@ -3251,7 +3434,7 @@
                 <a:ea typeface="Cambria" pitchFamily="34" charset="-122"/>
                 <a:cs typeface="Cambria" pitchFamily="34" charset="-120"/>
               </a:rPr>
-              <a:t>10. Bricks without straw</a:t>
+              <a:t>Bricks without straw</a:t>
             </a:r>
             <a:endParaRPr lang="en-US" sz="4000" dirty="0"/>
           </a:p>
@@ -3385,7 +3568,7 @@
                 <a:ea typeface="Cambria" pitchFamily="34" charset="-122"/>
                 <a:cs typeface="Cambria" pitchFamily="34" charset="-120"/>
               </a:rPr>
-              <a:t>11. The baby seal and the big bad dog</a:t>
+              <a:t>The baby seal and the big bad dog</a:t>
             </a:r>
             <a:endParaRPr lang="en-US" sz="4000" dirty="0"/>
           </a:p>

</xml_diff>